<commit_message>
Add dataset_stats tool; embed chase video + correct precision in decks
catchaser/dataset_stats.py: per-session + combined detector precision
(measured only on frames where the detector CLAIMED a cat) and pos/neg
composition, read from review_status.json. 5 tests.

Corrected stat: across 2 triaged sessions (244 frames) the detector has
198 cat-claims -> 197 confirmed, 1 box-fix, 0 false positives = 99.5%
precision (198 pos / 46 neg). The earlier '93%' miscounted nocat clicks on
already-empty frames as errors.

Decks: embed the 62s chase clip (iPhone 1080p 112MB -> 720p 2.6MB via
ffmpeg) as a new slide (HTML base64; PPTX add_movie + poster) and update
precision numbers. Compressed video + poster live in docs/ for reproducible
builds.

Co-Authored-By: Claude Opus 4.8 (1M context) <noreply@anthropic.com>
</commit_message>
<xml_diff>
--- a/docs/catchaser_presentation.pptx
+++ b/docs/catchaser_presentation.pptx
@@ -18,6 +18,7 @@
     <p:sldId id="266" r:id="rId17"/>
     <p:sldId id="267" r:id="rId18"/>
     <p:sldId id="268" r:id="rId19"/>
+    <p:sldId id="269" r:id="rId20"/>
   </p:sldIdLst>
   <p:sldSz cx="12191695" cy="6858000" type="screen4x3"/>
   <p:notesSz cx="6858000" cy="9144000"/>
@@ -3278,7 +3279,7 @@
                 </a:solidFill>
                 <a:latin typeface="Consolas"/>
               </a:rPr>
-              <a:t>// 09 · THE BLOOPER REEL · WHAT THE ROBOT THOUGHT WAS A CAT</a:t>
+              <a:t>// 08B · THE CHASE · UNCUT · IPHONE TAPE</a:t>
             </a:r>
           </a:p>
         </p:txBody>
@@ -3317,152 +3318,27 @@
                 </a:solidFill>
                 <a:latin typeface="Chakra Petch"/>
               </a:rPr>
-              <a:t>Failure analysis, with receipts</a:t>
+              <a:t>Roll the footage</a:t>
             </a:r>
           </a:p>
         </p:txBody>
       </p:sp>
       <p:pic>
         <p:nvPicPr>
-          <p:cNvPr id="4" name="Picture 3" descr="det_010.jpg"/>
+          <p:cNvPr id="4" name="catchaser_chase.mp4">
+            <a:hlinkClick r:id="" action="ppaction://media"/>
+          </p:cNvPr>
           <p:cNvPicPr>
             <a:picLocks noChangeAspect="1"/>
           </p:cNvPicPr>
-          <p:nvPr/>
-        </p:nvPicPr>
-        <p:blipFill>
-          <a:blip r:embed="rId2"/>
-          <a:stretch>
-            <a:fillRect/>
-          </a:stretch>
-        </p:blipFill>
-        <p:spPr>
-          <a:xfrm>
-            <a:off x="640080" y="1828800"/>
-            <a:ext cx="3566160" cy="2674620"/>
-          </a:xfrm>
-          <a:prstGeom prst="rect">
-            <a:avLst/>
-          </a:prstGeom>
-        </p:spPr>
-      </p:pic>
-      <p:sp>
-        <p:nvSpPr>
-          <p:cNvPr id="5" name="TextBox 4"/>
-          <p:cNvSpPr txBox="1"/>
-          <p:nvPr/>
-        </p:nvSpPr>
-        <p:spPr>
-          <a:xfrm>
-            <a:off x="640080" y="4503420"/>
-            <a:ext cx="3566160" cy="320040"/>
-          </a:xfrm>
-          <a:prstGeom prst="rect">
-            <a:avLst/>
-          </a:prstGeom>
-          <a:noFill/>
-        </p:spPr>
-        <p:txBody>
-          <a:bodyPr wrap="square">
-            <a:spAutoFit/>
-          </a:bodyPr>
-          <a:lstStyle/>
-          <a:p>
-            <a:r>
-              <a:rPr sz="1000">
-                <a:solidFill>
-                  <a:srgbClr val="7D967A"/>
-                </a:solidFill>
-                <a:latin typeface="Consolas"/>
-              </a:rPr>
-              <a:t>TRASH CAN + MOTION BLUR  </a:t>
-            </a:r>
-            <a:r>
-              <a:rPr sz="1000" b="1">
-                <a:solidFill>
-                  <a:srgbClr val="FF5470"/>
-                </a:solidFill>
-                <a:latin typeface="Consolas"/>
-              </a:rPr>
-              <a:t>0.41 ✗</a:t>
-            </a:r>
-          </a:p>
-        </p:txBody>
-      </p:sp>
-      <p:pic>
-        <p:nvPicPr>
-          <p:cNvPr id="6" name="Picture 5" descr="det_011.jpg"/>
-          <p:cNvPicPr>
-            <a:picLocks noChangeAspect="1"/>
-          </p:cNvPicPr>
-          <p:nvPr/>
-        </p:nvPicPr>
-        <p:blipFill>
-          <a:blip r:embed="rId3"/>
-          <a:stretch>
-            <a:fillRect/>
-          </a:stretch>
-        </p:blipFill>
-        <p:spPr>
-          <a:xfrm>
-            <a:off x="4343400" y="1828800"/>
-            <a:ext cx="3566160" cy="2674620"/>
-          </a:xfrm>
-          <a:prstGeom prst="rect">
-            <a:avLst/>
-          </a:prstGeom>
-        </p:spPr>
-      </p:pic>
-      <p:sp>
-        <p:nvSpPr>
-          <p:cNvPr id="7" name="TextBox 6"/>
-          <p:cNvSpPr txBox="1"/>
-          <p:nvPr/>
-        </p:nvSpPr>
-        <p:spPr>
-          <a:xfrm>
-            <a:off x="4343400" y="4503420"/>
-            <a:ext cx="3566160" cy="320040"/>
-          </a:xfrm>
-          <a:prstGeom prst="rect">
-            <a:avLst/>
-          </a:prstGeom>
-          <a:noFill/>
-        </p:spPr>
-        <p:txBody>
-          <a:bodyPr wrap="square">
-            <a:spAutoFit/>
-          </a:bodyPr>
-          <a:lstStyle/>
-          <a:p>
-            <a:r>
-              <a:rPr sz="1000">
-                <a:solidFill>
-                  <a:srgbClr val="7D967A"/>
-                </a:solidFill>
-                <a:latin typeface="Consolas"/>
-              </a:rPr>
-              <a:t>CRUMPLED JACKET  </a:t>
-            </a:r>
-            <a:r>
-              <a:rPr sz="1000" b="1">
-                <a:solidFill>
-                  <a:srgbClr val="FF5470"/>
-                </a:solidFill>
-                <a:latin typeface="Consolas"/>
-              </a:rPr>
-              <a:t>0.63 ✗</a:t>
-            </a:r>
-          </a:p>
-        </p:txBody>
-      </p:sp>
-      <p:pic>
-        <p:nvPicPr>
-          <p:cNvPr id="8" name="Picture 7" descr="det_008.jpg"/>
-          <p:cNvPicPr>
-            <a:picLocks noChangeAspect="1"/>
-          </p:cNvPicPr>
-          <p:nvPr/>
+          <p:nvPr>
+            <a:videoFile r:link="rId3"/>
+            <p:extLst>
+              <p:ext uri="{DAA4B4D4-6D71-4841-9C94-3DE7FCFB9230}">
+                <p14:media xmlns:p14="http://schemas.microsoft.com/office/powerpoint/2010/main" r:embed="rId2"/>
+              </p:ext>
+            </p:extLst>
+          </p:nvPr>
         </p:nvPicPr>
         <p:blipFill>
           <a:blip r:embed="rId4"/>
@@ -3472,8 +3348,8 @@
         </p:blipFill>
         <p:spPr>
           <a:xfrm>
-            <a:off x="8046720" y="1828800"/>
-            <a:ext cx="3566160" cy="2674620"/>
+            <a:off x="822960" y="1554480"/>
+            <a:ext cx="2834640" cy="5029200"/>
           </a:xfrm>
           <a:prstGeom prst="rect">
             <a:avLst/>
@@ -3482,82 +3358,218 @@
       </p:pic>
       <p:sp>
         <p:nvSpPr>
-          <p:cNvPr id="9" name="TextBox 8"/>
-          <p:cNvSpPr txBox="1"/>
+          <p:cNvPr id="5" name="Rectangle 4"/>
+          <p:cNvSpPr/>
           <p:nvPr/>
         </p:nvSpPr>
         <p:spPr>
           <a:xfrm>
-            <a:off x="8046720" y="4503420"/>
-            <a:ext cx="3566160" cy="320040"/>
+            <a:off x="4206240" y="1737360"/>
+            <a:ext cx="7315200" cy="3291840"/>
           </a:xfrm>
           <a:prstGeom prst="rect">
             <a:avLst/>
           </a:prstGeom>
-          <a:noFill/>
-        </p:spPr>
-        <p:txBody>
-          <a:bodyPr wrap="square">
-            <a:spAutoFit/>
-          </a:bodyPr>
-          <a:lstStyle/>
-          <a:p>
-            <a:r>
-              <a:rPr sz="1000">
+          <a:solidFill>
+            <a:srgbClr val="0D130C"/>
+          </a:solidFill>
+          <a:ln w="12700">
+            <a:solidFill>
+              <a:srgbClr val="22331F"/>
+            </a:solidFill>
+          </a:ln>
+        </p:spPr>
+        <p:style>
+          <a:lnRef idx="1">
+            <a:schemeClr val="accent1"/>
+          </a:lnRef>
+          <a:fillRef idx="3">
+            <a:schemeClr val="accent1"/>
+          </a:fillRef>
+          <a:effectRef idx="2">
+            <a:schemeClr val="accent1"/>
+          </a:effectRef>
+          <a:fontRef idx="minor">
+            <a:schemeClr val="lt1"/>
+          </a:fontRef>
+        </p:style>
+        <p:txBody>
+          <a:bodyPr rtlCol="0" anchor="ctr" wrap="none" lIns="120000" tIns="90000"/>
+          <a:lstStyle/>
+          <a:p>
+            <a:pPr algn="ctr">
+              <a:spcAft>
+                <a:spcPts val="200"/>
+              </a:spcAft>
+            </a:pPr>
+            <a:r>
+              <a:rPr sz="1300">
+                <a:solidFill>
+                  <a:srgbClr val="3D9A45"/>
+                </a:solidFill>
+                <a:latin typeface="Consolas"/>
+              </a:rPr>
+              <a:t>THE CHASE · IMG_3375</a:t>
+            </a:r>
+          </a:p>
+          <a:p>
+            <a:pPr>
+              <a:spcAft>
+                <a:spcPts val="200"/>
+              </a:spcAft>
+            </a:pPr>
+            <a:r>
+              <a:rPr sz="1300">
+                <a:solidFill>
+                  <a:srgbClr val="C9DFC2"/>
+                </a:solidFill>
+                <a:latin typeface="Consolas"/>
+              </a:rPr>
+              <a:t/>
+            </a:r>
+          </a:p>
+          <a:p>
+            <a:pPr>
+              <a:spcAft>
+                <a:spcPts val="200"/>
+              </a:spcAft>
+            </a:pPr>
+            <a:r>
+              <a:rPr sz="1300">
+                <a:solidFill>
+                  <a:srgbClr val="C9DFC2"/>
+                </a:solidFill>
+                <a:latin typeface="Consolas"/>
+              </a:rPr>
+              <a:t>source    1080p · 112 MB</a:t>
+            </a:r>
+          </a:p>
+          <a:p>
+            <a:pPr>
+              <a:spcAft>
+                <a:spcPts val="200"/>
+              </a:spcAft>
+            </a:pPr>
+            <a:r>
+              <a:rPr sz="1300">
+                <a:solidFill>
+                  <a:srgbClr val="6CFF5C"/>
+                </a:solidFill>
+                <a:latin typeface="Consolas"/>
+              </a:rPr>
+              <a:t>encoded   720p H.264 · 2.6 MB</a:t>
+            </a:r>
+          </a:p>
+          <a:p>
+            <a:pPr>
+              <a:spcAft>
+                <a:spcPts val="200"/>
+              </a:spcAft>
+            </a:pPr>
+            <a:r>
+              <a:rPr sz="1300">
+                <a:solidFill>
+                  <a:srgbClr val="C9DFC2"/>
+                </a:solidFill>
+                <a:latin typeface="Consolas"/>
+              </a:rPr>
+              <a:t>embedded  right here in this deck</a:t>
+            </a:r>
+          </a:p>
+          <a:p>
+            <a:pPr>
+              <a:spcAft>
+                <a:spcPts val="200"/>
+              </a:spcAft>
+            </a:pPr>
+            <a:r>
+              <a:rPr sz="1300">
+                <a:solidFill>
+                  <a:srgbClr val="C9DFC2"/>
+                </a:solidFill>
+                <a:latin typeface="Consolas"/>
+              </a:rPr>
+              <a:t/>
+            </a:r>
+          </a:p>
+          <a:p>
+            <a:pPr>
+              <a:spcAft>
+                <a:spcPts val="200"/>
+              </a:spcAft>
+            </a:pPr>
+            <a:r>
+              <a:rPr sz="1300">
                 <a:solidFill>
                   <a:srgbClr val="7D967A"/>
                 </a:solidFill>
                 <a:latin typeface="Consolas"/>
               </a:rPr>
-              <a:t>IPAD DECOY (intentional)  </a:t>
-            </a:r>
-            <a:r>
-              <a:rPr sz="1000" b="1">
-                <a:solidFill>
-                  <a:srgbClr val="6CFF5C"/>
-                </a:solidFill>
-                <a:latin typeface="Consolas"/>
-              </a:rPr>
-              <a:t>0.62 ✓</a:t>
-            </a:r>
-          </a:p>
-        </p:txBody>
-      </p:sp>
-      <p:sp>
-        <p:nvSpPr>
-          <p:cNvPr id="10" name="TextBox 9"/>
-          <p:cNvSpPr txBox="1"/>
-          <p:nvPr/>
-        </p:nvSpPr>
-        <p:spPr>
-          <a:xfrm>
-            <a:off x="640080" y="5212080"/>
-            <a:ext cx="10972800" cy="1188720"/>
-          </a:xfrm>
-          <a:prstGeom prst="rect">
-            <a:avLst/>
-          </a:prstGeom>
-          <a:noFill/>
-        </p:spPr>
-        <p:txBody>
-          <a:bodyPr wrap="square">
-            <a:spAutoFit/>
-          </a:bodyPr>
-          <a:lstStyle/>
-          <a:p>
-            <a:pPr>
-              <a:spcAft>
-                <a:spcPts val="600"/>
-              </a:spcAft>
-            </a:pPr>
-            <a:r>
-              <a:rPr sz="1200" b="0">
+              <a:t>the loop from the slides, running</a:t>
+            </a:r>
+          </a:p>
+          <a:p>
+            <a:pPr>
+              <a:spcAft>
+                <a:spcPts val="200"/>
+              </a:spcAft>
+            </a:pPr>
+            <a:r>
+              <a:rPr sz="1300">
                 <a:solidFill>
                   <a:srgbClr val="7D967A"/>
                 </a:solidFill>
                 <a:latin typeface="Consolas"/>
               </a:rPr>
-              <a:t>Lessons burned in: rotation blur is the enemy (spin-and-stare) · dim screens defeat decoys (max brightness) · every config threshold now cites the field frame that set it · and the "unreachable robot" was a stale WiFi profile broadcasting a dead address — trust nmcli, not the OLED.</a:t>
+              <a:t>for real: acquire, center, approach,</a:t>
+            </a:r>
+          </a:p>
+          <a:p>
+            <a:pPr>
+              <a:spcAft>
+                <a:spcPts val="200"/>
+              </a:spcAft>
+            </a:pPr>
+            <a:r>
+              <a:rPr sz="1300">
+                <a:solidFill>
+                  <a:srgbClr val="7D967A"/>
+                </a:solidFill>
+                <a:latin typeface="Consolas"/>
+              </a:rPr>
+              <a:t>and the cat's considered response.</a:t>
+            </a:r>
+          </a:p>
+          <a:p>
+            <a:pPr>
+              <a:spcAft>
+                <a:spcPts val="200"/>
+              </a:spcAft>
+            </a:pPr>
+            <a:r>
+              <a:rPr sz="1300">
+                <a:solidFill>
+                  <a:srgbClr val="C9DFC2"/>
+                </a:solidFill>
+                <a:latin typeface="Consolas"/>
+              </a:rPr>
+              <a:t/>
+            </a:r>
+          </a:p>
+          <a:p>
+            <a:pPr>
+              <a:spcAft>
+                <a:spcPts val="200"/>
+              </a:spcAft>
+            </a:pPr>
+            <a:r>
+              <a:rPr sz="1300">
+                <a:solidFill>
+                  <a:srgbClr val="FFB454"/>
+                </a:solidFill>
+                <a:latin typeface="Consolas"/>
+              </a:rPr>
+              <a:t>verdict   cat: unbothered</a:t>
             </a:r>
           </a:p>
         </p:txBody>
@@ -3567,6 +3579,28 @@
   <p:clrMapOvr>
     <a:masterClrMapping/>
   </p:clrMapOvr>
+  <p:timing>
+    <p:tnLst>
+      <p:par>
+        <p:cTn id="1" dur="indefinite" restart="never" nodeType="tmRoot">
+          <p:childTnLst>
+            <p:video>
+              <p:cMediaNode vol="80000">
+                <p:cTn id="2" fill="hold" display="0">
+                  <p:stCondLst>
+                    <p:cond delay="indefinite"/>
+                  </p:stCondLst>
+                </p:cTn>
+                <p:tgtEl>
+                  <p:spTgt spid="4"/>
+                </p:tgtEl>
+              </p:cMediaNode>
+            </p:video>
+          </p:childTnLst>
+        </p:cTn>
+      </p:par>
+    </p:tnLst>
+  </p:timing>
 </p:sld>
 </file>
 
@@ -3622,7 +3656,7 @@
                 </a:solidFill>
                 <a:latin typeface="Consolas"/>
               </a:rPr>
-              <a:t>// 10 · DATASET PIPELINE · COUCH-DRIVEN ML-OPS</a:t>
+              <a:t>// 09 · THE BLOOPER REEL · WHAT THE ROBOT THOUGHT WAS A CAT</a:t>
             </a:r>
           </a:p>
         </p:txBody>
@@ -3661,213 +3695,35 @@
                 </a:solidFill>
                 <a:latin typeface="Chakra Petch"/>
               </a:rPr>
-              <a:t>Chase -&gt; harvest -&gt; thumb-triage</a:t>
-            </a:r>
-          </a:p>
-        </p:txBody>
-      </p:sp>
-      <p:sp>
-        <p:nvSpPr>
-          <p:cNvPr id="4" name="Rectangle 3"/>
-          <p:cNvSpPr/>
+              <a:t>Failure analysis, with receipts</a:t>
+            </a:r>
+          </a:p>
+        </p:txBody>
+      </p:sp>
+      <p:pic>
+        <p:nvPicPr>
+          <p:cNvPr id="4" name="Picture 3" descr="det_010.jpg"/>
+          <p:cNvPicPr>
+            <a:picLocks noChangeAspect="1"/>
+          </p:cNvPicPr>
           <p:nvPr/>
-        </p:nvSpPr>
-        <p:spPr>
-          <a:xfrm>
-            <a:off x="640080" y="1737360"/>
-            <a:ext cx="5486400" cy="3108960"/>
+        </p:nvPicPr>
+        <p:blipFill>
+          <a:blip r:embed="rId2"/>
+          <a:stretch>
+            <a:fillRect/>
+          </a:stretch>
+        </p:blipFill>
+        <p:spPr>
+          <a:xfrm>
+            <a:off x="640080" y="1828800"/>
+            <a:ext cx="3566160" cy="2674620"/>
           </a:xfrm>
           <a:prstGeom prst="rect">
             <a:avLst/>
           </a:prstGeom>
-          <a:solidFill>
-            <a:srgbClr val="0D130C"/>
-          </a:solidFill>
-          <a:ln w="12700">
-            <a:solidFill>
-              <a:srgbClr val="22331F"/>
-            </a:solidFill>
-          </a:ln>
-        </p:spPr>
-        <p:style>
-          <a:lnRef idx="1">
-            <a:schemeClr val="accent1"/>
-          </a:lnRef>
-          <a:fillRef idx="3">
-            <a:schemeClr val="accent1"/>
-          </a:fillRef>
-          <a:effectRef idx="2">
-            <a:schemeClr val="accent1"/>
-          </a:effectRef>
-          <a:fontRef idx="minor">
-            <a:schemeClr val="lt1"/>
-          </a:fontRef>
-        </p:style>
-        <p:txBody>
-          <a:bodyPr rtlCol="0" anchor="ctr" wrap="none" lIns="120000" tIns="90000"/>
-          <a:lstStyle/>
-          <a:p>
-            <a:pPr algn="ctr">
-              <a:spcAft>
-                <a:spcPts val="200"/>
-              </a:spcAft>
-            </a:pPr>
-            <a:r>
-              <a:rPr sz="1200">
-                <a:solidFill>
-                  <a:srgbClr val="3D9A45"/>
-                </a:solidFill>
-                <a:latin typeface="Consolas"/>
-              </a:rPr>
-              <a:t>PHONE WORKFLOW</a:t>
-            </a:r>
-          </a:p>
-          <a:p>
-            <a:pPr>
-              <a:spcAft>
-                <a:spcPts val="200"/>
-              </a:spcAft>
-            </a:pPr>
-            <a:r>
-              <a:rPr sz="1200">
-                <a:solidFill>
-                  <a:srgbClr val="C9DFC2"/>
-                </a:solidFill>
-                <a:latin typeface="Consolas"/>
-              </a:rPr>
-              <a:t/>
-            </a:r>
-          </a:p>
-          <a:p>
-            <a:pPr>
-              <a:spcAft>
-                <a:spcPts val="200"/>
-              </a:spcAft>
-            </a:pPr>
-            <a:r>
-              <a:rPr sz="1200">
-                <a:solidFill>
-                  <a:srgbClr val="EAFFE6"/>
-                </a:solidFill>
-                <a:latin typeface="Consolas"/>
-              </a:rPr>
-              <a:t>$ ./harvest.sh    # chase + collect (&lt;=1/s dets,</a:t>
-            </a:r>
-          </a:p>
-          <a:p>
-            <a:pPr>
-              <a:spcAft>
-                <a:spcPts val="200"/>
-              </a:spcAft>
-            </a:pPr>
-            <a:r>
-              <a:rPr sz="1200">
-                <a:solidFill>
-                  <a:srgbClr val="7D967A"/>
-                </a:solidFill>
-                <a:latin typeface="Consolas"/>
-              </a:rPr>
-              <a:t>                  #  1/10s negatives, cap 300)</a:t>
-            </a:r>
-          </a:p>
-          <a:p>
-            <a:pPr>
-              <a:spcAft>
-                <a:spcPts val="200"/>
-              </a:spcAft>
-            </a:pPr>
-            <a:r>
-              <a:rPr sz="1200">
-                <a:solidFill>
-                  <a:srgbClr val="EAFFE6"/>
-                </a:solidFill>
-                <a:latin typeface="Consolas"/>
-              </a:rPr>
-              <a:t>$ ./review.sh     # triage web server :5000</a:t>
-            </a:r>
-          </a:p>
-          <a:p>
-            <a:pPr>
-              <a:spcAft>
-                <a:spcPts val="200"/>
-              </a:spcAft>
-            </a:pPr>
-            <a:r>
-              <a:rPr sz="1200">
-                <a:solidFill>
-                  <a:srgbClr val="C9DFC2"/>
-                </a:solidFill>
-                <a:latin typeface="Consolas"/>
-              </a:rPr>
-              <a:t/>
-            </a:r>
-          </a:p>
-          <a:p>
-            <a:pPr>
-              <a:spcAft>
-                <a:spcPts val="200"/>
-              </a:spcAft>
-            </a:pPr>
-            <a:r>
-              <a:rPr sz="1200">
-                <a:solidFill>
-                  <a:srgbClr val="6CFF5C"/>
-                </a:solidFill>
-                <a:latin typeface="Consolas"/>
-              </a:rPr>
-              <a:t>g = Good    keep detector's box</a:t>
-            </a:r>
-          </a:p>
-          <a:p>
-            <a:pPr>
-              <a:spcAft>
-                <a:spcPts val="200"/>
-              </a:spcAft>
-            </a:pPr>
-            <a:r>
-              <a:rPr sz="1200">
-                <a:solidFill>
-                  <a:srgbClr val="FF5470"/>
-                </a:solidFill>
-                <a:latin typeface="Consolas"/>
-              </a:rPr>
-              <a:t>n = No cat  force clean negative</a:t>
-            </a:r>
-          </a:p>
-          <a:p>
-            <a:pPr>
-              <a:spcAft>
-                <a:spcPts val="200"/>
-              </a:spcAft>
-            </a:pPr>
-            <a:r>
-              <a:rPr sz="1200">
-                <a:solidFill>
-                  <a:srgbClr val="FFB454"/>
-                </a:solidFill>
-                <a:latin typeface="Consolas"/>
-              </a:rPr>
-              <a:t>f = Fix     route to real box editor</a:t>
-            </a:r>
-          </a:p>
-          <a:p>
-            <a:pPr>
-              <a:spcAft>
-                <a:spcPts val="200"/>
-              </a:spcAft>
-            </a:pPr>
-            <a:r>
-              <a:rPr sz="1200">
-                <a:solidFill>
-                  <a:srgbClr val="5EE6D0"/>
-                </a:solidFill>
-                <a:latin typeface="Consolas"/>
-              </a:rPr>
-              <a:t>u = Undo    lossless, resume anytime</a:t>
-            </a:r>
-          </a:p>
-        </p:txBody>
-      </p:sp>
+        </p:spPr>
+      </p:pic>
       <p:sp>
         <p:nvSpPr>
           <p:cNvPr id="5" name="TextBox 4"/>
@@ -3876,8 +3732,8 @@
         </p:nvSpPr>
         <p:spPr>
           <a:xfrm>
-            <a:off x="6675120" y="1828800"/>
-            <a:ext cx="2377440" cy="1005840"/>
+            <a:off x="640080" y="4503420"/>
+            <a:ext cx="3566160" cy="320040"/>
           </a:xfrm>
           <a:prstGeom prst="rect">
             <a:avLst/>
@@ -3890,49 +3746,61 @@
           </a:bodyPr>
           <a:lstStyle/>
           <a:p>
-            <a:pPr>
-              <a:spcAft>
-                <a:spcPts val="0"/>
-              </a:spcAft>
-            </a:pPr>
-            <a:r>
-              <a:rPr sz="3200" b="1">
-                <a:solidFill>
-                  <a:srgbClr val="6CFF5C"/>
-                </a:solidFill>
-                <a:latin typeface="Chakra Petch"/>
-              </a:rPr>
-              <a:t>172</a:t>
-            </a:r>
-          </a:p>
-          <a:p>
-            <a:pPr>
-              <a:spcAft>
-                <a:spcPts val="0"/>
-              </a:spcAft>
-            </a:pPr>
-            <a:r>
-              <a:rPr sz="900" b="0">
+            <a:r>
+              <a:rPr sz="1000">
                 <a:solidFill>
                   <a:srgbClr val="7D967A"/>
                 </a:solidFill>
                 <a:latin typeface="Consolas"/>
               </a:rPr>
-              <a:t>FRAMES TRIAGED · SESSION 1</a:t>
-            </a:r>
-          </a:p>
-        </p:txBody>
-      </p:sp>
-      <p:sp>
-        <p:nvSpPr>
-          <p:cNvPr id="6" name="TextBox 5"/>
+              <a:t>TRASH CAN + MOTION BLUR  </a:t>
+            </a:r>
+            <a:r>
+              <a:rPr sz="1000" b="1">
+                <a:solidFill>
+                  <a:srgbClr val="FF5470"/>
+                </a:solidFill>
+                <a:latin typeface="Consolas"/>
+              </a:rPr>
+              <a:t>0.41 ✗</a:t>
+            </a:r>
+          </a:p>
+        </p:txBody>
+      </p:sp>
+      <p:pic>
+        <p:nvPicPr>
+          <p:cNvPr id="6" name="Picture 5" descr="det_011.jpg"/>
+          <p:cNvPicPr>
+            <a:picLocks noChangeAspect="1"/>
+          </p:cNvPicPr>
+          <p:nvPr/>
+        </p:nvPicPr>
+        <p:blipFill>
+          <a:blip r:embed="rId3"/>
+          <a:stretch>
+            <a:fillRect/>
+          </a:stretch>
+        </p:blipFill>
+        <p:spPr>
+          <a:xfrm>
+            <a:off x="4343400" y="1828800"/>
+            <a:ext cx="3566160" cy="2674620"/>
+          </a:xfrm>
+          <a:prstGeom prst="rect">
+            <a:avLst/>
+          </a:prstGeom>
+        </p:spPr>
+      </p:pic>
+      <p:sp>
+        <p:nvSpPr>
+          <p:cNvPr id="7" name="TextBox 6"/>
           <p:cNvSpPr txBox="1"/>
           <p:nvPr/>
         </p:nvSpPr>
         <p:spPr>
           <a:xfrm>
-            <a:off x="9052560" y="1828800"/>
-            <a:ext cx="2377440" cy="1005840"/>
+            <a:off x="4343400" y="4503420"/>
+            <a:ext cx="3566160" cy="320040"/>
           </a:xfrm>
           <a:prstGeom prst="rect">
             <a:avLst/>
@@ -3945,49 +3813,61 @@
           </a:bodyPr>
           <a:lstStyle/>
           <a:p>
-            <a:pPr>
-              <a:spcAft>
-                <a:spcPts val="0"/>
-              </a:spcAft>
-            </a:pPr>
-            <a:r>
-              <a:rPr sz="3200" b="1">
-                <a:solidFill>
-                  <a:srgbClr val="6CFF5C"/>
-                </a:solidFill>
-                <a:latin typeface="Chakra Petch"/>
-              </a:rPr>
-              <a:t>93%</a:t>
-            </a:r>
-          </a:p>
-          <a:p>
-            <a:pPr>
-              <a:spcAft>
-                <a:spcPts val="0"/>
-              </a:spcAft>
-            </a:pPr>
-            <a:r>
-              <a:rPr sz="900" b="0">
+            <a:r>
+              <a:rPr sz="1000">
                 <a:solidFill>
                   <a:srgbClr val="7D967A"/>
                 </a:solidFill>
                 <a:latin typeface="Consolas"/>
               </a:rPr>
-              <a:t>RAW DETECTOR PRECISION</a:t>
-            </a:r>
-          </a:p>
-        </p:txBody>
-      </p:sp>
-      <p:sp>
-        <p:nvSpPr>
-          <p:cNvPr id="7" name="TextBox 6"/>
+              <a:t>CRUMPLED JACKET  </a:t>
+            </a:r>
+            <a:r>
+              <a:rPr sz="1000" b="1">
+                <a:solidFill>
+                  <a:srgbClr val="FF5470"/>
+                </a:solidFill>
+                <a:latin typeface="Consolas"/>
+              </a:rPr>
+              <a:t>0.63 ✗</a:t>
+            </a:r>
+          </a:p>
+        </p:txBody>
+      </p:sp>
+      <p:pic>
+        <p:nvPicPr>
+          <p:cNvPr id="8" name="Picture 7" descr="det_008.jpg"/>
+          <p:cNvPicPr>
+            <a:picLocks noChangeAspect="1"/>
+          </p:cNvPicPr>
+          <p:nvPr/>
+        </p:nvPicPr>
+        <p:blipFill>
+          <a:blip r:embed="rId4"/>
+          <a:stretch>
+            <a:fillRect/>
+          </a:stretch>
+        </p:blipFill>
+        <p:spPr>
+          <a:xfrm>
+            <a:off x="8046720" y="1828800"/>
+            <a:ext cx="3566160" cy="2674620"/>
+          </a:xfrm>
+          <a:prstGeom prst="rect">
+            <a:avLst/>
+          </a:prstGeom>
+        </p:spPr>
+      </p:pic>
+      <p:sp>
+        <p:nvSpPr>
+          <p:cNvPr id="9" name="TextBox 8"/>
           <p:cNvSpPr txBox="1"/>
           <p:nvPr/>
         </p:nvSpPr>
         <p:spPr>
           <a:xfrm>
-            <a:off x="6675120" y="3017520"/>
-            <a:ext cx="2377440" cy="1005840"/>
+            <a:off x="8046720" y="4503420"/>
+            <a:ext cx="3566160" cy="320040"/>
           </a:xfrm>
           <a:prstGeom prst="rect">
             <a:avLst/>
@@ -4000,49 +3880,37 @@
           </a:bodyPr>
           <a:lstStyle/>
           <a:p>
-            <a:pPr>
-              <a:spcAft>
-                <a:spcPts val="0"/>
-              </a:spcAft>
-            </a:pPr>
-            <a:r>
-              <a:rPr sz="3200" b="1">
+            <a:r>
+              <a:rPr sz="1000">
+                <a:solidFill>
+                  <a:srgbClr val="7D967A"/>
+                </a:solidFill>
+                <a:latin typeface="Consolas"/>
+              </a:rPr>
+              <a:t>IPAD DECOY (intentional)  </a:t>
+            </a:r>
+            <a:r>
+              <a:rPr sz="1000" b="1">
                 <a:solidFill>
                   <a:srgbClr val="6CFF5C"/>
                 </a:solidFill>
-                <a:latin typeface="Chakra Petch"/>
-              </a:rPr>
-              <a:t>143/29</a:t>
-            </a:r>
-          </a:p>
-          <a:p>
-            <a:pPr>
-              <a:spcAft>
-                <a:spcPts val="0"/>
-              </a:spcAft>
-            </a:pPr>
-            <a:r>
-              <a:rPr sz="900" b="0">
-                <a:solidFill>
-                  <a:srgbClr val="7D967A"/>
-                </a:solidFill>
-                <a:latin typeface="Consolas"/>
-              </a:rPr>
-              <a:t>POSITIVES / NEGATIVES</a:t>
-            </a:r>
-          </a:p>
-        </p:txBody>
-      </p:sp>
-      <p:sp>
-        <p:nvSpPr>
-          <p:cNvPr id="8" name="TextBox 7"/>
+                <a:latin typeface="Consolas"/>
+              </a:rPr>
+              <a:t>0.62 ✓</a:t>
+            </a:r>
+          </a:p>
+        </p:txBody>
+      </p:sp>
+      <p:sp>
+        <p:nvSpPr>
+          <p:cNvPr id="10" name="TextBox 9"/>
           <p:cNvSpPr txBox="1"/>
           <p:nvPr/>
         </p:nvSpPr>
         <p:spPr>
           <a:xfrm>
-            <a:off x="9052560" y="3017520"/>
-            <a:ext cx="2377440" cy="1005840"/>
+            <a:off x="640080" y="5212080"/>
+            <a:ext cx="10972800" cy="1188720"/>
           </a:xfrm>
           <a:prstGeom prst="rect">
             <a:avLst/>
@@ -4057,72 +3925,17 @@
           <a:p>
             <a:pPr>
               <a:spcAft>
-                <a:spcPts val="0"/>
-              </a:spcAft>
-            </a:pPr>
-            <a:r>
-              <a:rPr sz="3200" b="1">
-                <a:solidFill>
-                  <a:srgbClr val="5EE6D0"/>
-                </a:solidFill>
-                <a:latin typeface="Chakra Petch"/>
-              </a:rPr>
-              <a:t>160·11·1</a:t>
-            </a:r>
-          </a:p>
-          <a:p>
-            <a:pPr>
-              <a:spcAft>
-                <a:spcPts val="0"/>
-              </a:spcAft>
-            </a:pPr>
-            <a:r>
-              <a:rPr sz="900" b="0">
+                <a:spcPts val="600"/>
+              </a:spcAft>
+            </a:pPr>
+            <a:r>
+              <a:rPr sz="1200" b="0">
                 <a:solidFill>
                   <a:srgbClr val="7D967A"/>
                 </a:solidFill>
                 <a:latin typeface="Consolas"/>
               </a:rPr>
-              <a:t>GOOD · NO-CAT · FIX</a:t>
-            </a:r>
-          </a:p>
-        </p:txBody>
-      </p:sp>
-      <p:sp>
-        <p:nvSpPr>
-          <p:cNvPr id="9" name="TextBox 8"/>
-          <p:cNvSpPr txBox="1"/>
-          <p:nvPr/>
-        </p:nvSpPr>
-        <p:spPr>
-          <a:xfrm>
-            <a:off x="6675120" y="4206240"/>
-            <a:ext cx="4846320" cy="1828800"/>
-          </a:xfrm>
-          <a:prstGeom prst="rect">
-            <a:avLst/>
-          </a:prstGeom>
-          <a:noFill/>
-        </p:spPr>
-        <p:txBody>
-          <a:bodyPr wrap="square">
-            <a:spAutoFit/>
-          </a:bodyPr>
-          <a:lstStyle/>
-          <a:p>
-            <a:pPr>
-              <a:spcAft>
-                <a:spcPts val="600"/>
-              </a:spcAft>
-            </a:pPr>
-            <a:r>
-              <a:rPr sz="1200" b="0">
-                <a:solidFill>
-                  <a:srgbClr val="7D967A"/>
-                </a:solidFill>
-                <a:latin typeface="Consolas"/>
-              </a:rPr>
-              <a:t>Verdict: the pretrained net is good enough that fine-tuning waits for ~500 varied positives. Session 1 becomes the eval set any future model must beat.</a:t>
+              <a:t>Lessons burned in: rotation blur is the enemy (spin-and-stare) · dim screens defeat decoys (max brightness) · every config threshold now cites the field frame that set it · and the "unreachable robot" was a stale WiFi profile broadcasting a dead address — trust nmcli, not the OLED.</a:t>
             </a:r>
           </a:p>
         </p:txBody>
@@ -4187,7 +4000,7 @@
                 </a:solidFill>
                 <a:latin typeface="Consolas"/>
               </a:rPr>
-              <a:t>// 11 · ROADMAP</a:t>
+              <a:t>// 10 · DATASET PIPELINE · COUCH-DRIVEN ML-OPS</a:t>
             </a:r>
           </a:p>
         </p:txBody>
@@ -4226,144 +4039,21 @@
                 </a:solidFill>
                 <a:latin typeface="Chakra Petch"/>
               </a:rPr>
-              <a:t>Next sorties + the SLAM campaign</a:t>
-            </a:r>
-          </a:p>
-        </p:txBody>
-      </p:sp>
-      <p:sp>
-        <p:nvSpPr>
-          <p:cNvPr id="4" name="TextBox 3"/>
-          <p:cNvSpPr txBox="1"/>
-          <p:nvPr/>
-        </p:nvSpPr>
-        <p:spPr>
-          <a:xfrm>
-            <a:off x="640080" y="1737360"/>
-            <a:ext cx="5852160" cy="4572000"/>
-          </a:xfrm>
-          <a:prstGeom prst="rect">
-            <a:avLst/>
-          </a:prstGeom>
-          <a:noFill/>
-        </p:spPr>
-        <p:txBody>
-          <a:bodyPr wrap="square">
-            <a:spAutoFit/>
-          </a:bodyPr>
-          <a:lstStyle/>
-          <a:p>
-            <a:pPr>
-              <a:spcAft>
-                <a:spcPts val="1000"/>
-              </a:spcAft>
-            </a:pPr>
-            <a:r>
-              <a:rPr sz="1300" b="1">
-                <a:solidFill>
-                  <a:srgbClr val="EAFFE6"/>
-                </a:solidFill>
-                <a:latin typeface="Consolas"/>
-              </a:rPr>
-              <a:t>▸ Pan-servo search  </a:t>
-            </a:r>
-            <a:r>
-              <a:rPr sz="1300">
-                <a:solidFill>
-                  <a:srgbClr val="7D967A"/>
-                </a:solidFill>
-                <a:latin typeface="Consolas"/>
-              </a:rPr>
-              <a:t>sweep the camera, not the chassis: sharp frames, 3x coverage, zero blur. One servo-sign check away.</a:t>
-            </a:r>
-          </a:p>
-          <a:p>
-            <a:pPr>
-              <a:spcAft>
-                <a:spcPts val="1000"/>
-              </a:spcAft>
-            </a:pPr>
-            <a:r>
-              <a:rPr sz="1300" b="1">
-                <a:solidFill>
-                  <a:srgbClr val="EAFFE6"/>
-                </a:solidFill>
-                <a:latin typeface="Consolas"/>
-              </a:rPr>
-              <a:t>▸ Exposure control  </a:t>
-            </a:r>
-            <a:r>
-              <a:rPr sz="1300">
-                <a:solidFill>
-                  <a:srgbClr val="7D967A"/>
-                </a:solidFill>
-                <a:latin typeface="Consolas"/>
-              </a:rPr>
-              <a:t>shorter shutter to cut rotation blur at the source.</a:t>
-            </a:r>
-          </a:p>
-          <a:p>
-            <a:pPr>
-              <a:spcAft>
-                <a:spcPts val="1000"/>
-              </a:spcAft>
-            </a:pPr>
-            <a:r>
-              <a:rPr sz="1300" b="1">
-                <a:solidFill>
-                  <a:srgbClr val="EAFFE6"/>
-                </a:solidFill>
-                <a:latin typeface="Consolas"/>
-              </a:rPr>
-              <a:t>▸ Lead pursuit  </a:t>
-            </a:r>
-            <a:r>
-              <a:rPr sz="1300">
-                <a:solidFill>
-                  <a:srgbClr val="7D967A"/>
-                </a:solidFill>
-                <a:latin typeface="Consolas"/>
-              </a:rPr>
-              <a:t>centroid velocity prediction, for when the Bengal stops going easy.</a:t>
-            </a:r>
-          </a:p>
-          <a:p>
-            <a:pPr>
-              <a:spcAft>
-                <a:spcPts val="1000"/>
-              </a:spcAft>
-            </a:pPr>
-            <a:r>
-              <a:rPr sz="1300" b="1">
-                <a:solidFill>
-                  <a:srgbClr val="EAFFE6"/>
-                </a:solidFill>
-                <a:latin typeface="Consolas"/>
-              </a:rPr>
-              <a:t>▸ IR kill verification  </a:t>
-            </a:r>
-            <a:r>
-              <a:rPr sz="1300">
-                <a:solidFill>
-                  <a:srgbClr val="7D967A"/>
-                </a:solidFill>
-                <a:latin typeface="Consolas"/>
-              </a:rPr>
-              <a:t>the last unchecked box before unsupervised roaming.</a:t>
-            </a:r>
-          </a:p>
-        </p:txBody>
-      </p:sp>
-      <p:sp>
-        <p:nvSpPr>
-          <p:cNvPr id="5" name="Rectangle 4"/>
+              <a:t>Chase -&gt; harvest -&gt; thumb-triage</a:t>
+            </a:r>
+          </a:p>
+        </p:txBody>
+      </p:sp>
+      <p:sp>
+        <p:nvSpPr>
+          <p:cNvPr id="4" name="Rectangle 3"/>
           <p:cNvSpPr/>
           <p:nvPr/>
         </p:nvSpPr>
         <p:spPr>
           <a:xfrm>
-            <a:off x="6766560" y="1737360"/>
-            <a:ext cx="4846320" cy="3291840"/>
+            <a:off x="640080" y="1737360"/>
+            <a:ext cx="5486400" cy="3108960"/>
           </a:xfrm>
           <a:prstGeom prst="rect">
             <a:avLst/>
@@ -4401,23 +4091,23 @@
               </a:spcAft>
             </a:pPr>
             <a:r>
-              <a:rPr sz="1100">
+              <a:rPr sz="1200">
                 <a:solidFill>
                   <a:srgbClr val="3D9A45"/>
                 </a:solidFill>
                 <a:latin typeface="Consolas"/>
               </a:rPr>
-              <a:t>SLAM CAMPAIGN (separate track)</a:t>
-            </a:r>
-          </a:p>
-          <a:p>
-            <a:pPr>
-              <a:spcAft>
-                <a:spcPts val="200"/>
-              </a:spcAft>
-            </a:pPr>
-            <a:r>
-              <a:rPr sz="1100">
+              <a:t>PHONE WORKFLOW</a:t>
+            </a:r>
+          </a:p>
+          <a:p>
+            <a:pPr>
+              <a:spcAft>
+                <a:spcPts val="200"/>
+              </a:spcAft>
+            </a:pPr>
+            <a:r>
+              <a:rPr sz="1200">
                 <a:solidFill>
                   <a:srgbClr val="C9DFC2"/>
                 </a:solidFill>
@@ -4433,157 +4123,384 @@
               </a:spcAft>
             </a:pPr>
             <a:r>
-              <a:rPr sz="1100">
+              <a:rPr sz="1200">
+                <a:solidFill>
+                  <a:srgbClr val="EAFFE6"/>
+                </a:solidFill>
+                <a:latin typeface="Consolas"/>
+              </a:rPr>
+              <a:t>$ ./harvest.sh    # chase + collect (&lt;=1/s dets,</a:t>
+            </a:r>
+          </a:p>
+          <a:p>
+            <a:pPr>
+              <a:spcAft>
+                <a:spcPts val="200"/>
+              </a:spcAft>
+            </a:pPr>
+            <a:r>
+              <a:rPr sz="1200">
                 <a:solidFill>
                   <a:srgbClr val="7D967A"/>
                 </a:solidFill>
                 <a:latin typeface="Consolas"/>
               </a:rPr>
-              <a:t>external review: no metric map possible yet</a:t>
-            </a:r>
-          </a:p>
-          <a:p>
-            <a:pPr>
-              <a:spcAft>
-                <a:spcPts val="200"/>
-              </a:spcAft>
-            </a:pPr>
-            <a:r>
-              <a:rPr sz="1100">
+              <a:t>                  #  1/10s negatives, cap 300)</a:t>
+            </a:r>
+          </a:p>
+          <a:p>
+            <a:pPr>
+              <a:spcAft>
+                <a:spcPts val="200"/>
+              </a:spcAft>
+            </a:pPr>
+            <a:r>
+              <a:rPr sz="1200">
+                <a:solidFill>
+                  <a:srgbClr val="EAFFE6"/>
+                </a:solidFill>
+                <a:latin typeface="Consolas"/>
+              </a:rPr>
+              <a:t>$ ./review.sh     # triage web server :5000</a:t>
+            </a:r>
+          </a:p>
+          <a:p>
+            <a:pPr>
+              <a:spcAft>
+                <a:spcPts val="200"/>
+              </a:spcAft>
+            </a:pPr>
+            <a:r>
+              <a:rPr sz="1200">
+                <a:solidFill>
+                  <a:srgbClr val="C9DFC2"/>
+                </a:solidFill>
+                <a:latin typeface="Consolas"/>
+              </a:rPr>
+              <a:t/>
+            </a:r>
+          </a:p>
+          <a:p>
+            <a:pPr>
+              <a:spcAft>
+                <a:spcPts val="200"/>
+              </a:spcAft>
+            </a:pPr>
+            <a:r>
+              <a:rPr sz="1200">
+                <a:solidFill>
+                  <a:srgbClr val="6CFF5C"/>
+                </a:solidFill>
+                <a:latin typeface="Consolas"/>
+              </a:rPr>
+              <a:t>g = Good    keep detector's box</a:t>
+            </a:r>
+          </a:p>
+          <a:p>
+            <a:pPr>
+              <a:spcAft>
+                <a:spcPts val="200"/>
+              </a:spcAft>
+            </a:pPr>
+            <a:r>
+              <a:rPr sz="1200">
+                <a:solidFill>
+                  <a:srgbClr val="FF5470"/>
+                </a:solidFill>
+                <a:latin typeface="Consolas"/>
+              </a:rPr>
+              <a:t>n = No cat  force clean negative</a:t>
+            </a:r>
+          </a:p>
+          <a:p>
+            <a:pPr>
+              <a:spcAft>
+                <a:spcPts val="200"/>
+              </a:spcAft>
+            </a:pPr>
+            <a:r>
+              <a:rPr sz="1200">
+                <a:solidFill>
+                  <a:srgbClr val="FFB454"/>
+                </a:solidFill>
+                <a:latin typeface="Consolas"/>
+              </a:rPr>
+              <a:t>f = Fix     route to real box editor</a:t>
+            </a:r>
+          </a:p>
+          <a:p>
+            <a:pPr>
+              <a:spcAft>
+                <a:spcPts val="200"/>
+              </a:spcAft>
+            </a:pPr>
+            <a:r>
+              <a:rPr sz="1200">
+                <a:solidFill>
+                  <a:srgbClr val="5EE6D0"/>
+                </a:solidFill>
+                <a:latin typeface="Consolas"/>
+              </a:rPr>
+              <a:t>u = Undo    lossless, resume anytime</a:t>
+            </a:r>
+          </a:p>
+        </p:txBody>
+      </p:sp>
+      <p:sp>
+        <p:nvSpPr>
+          <p:cNvPr id="5" name="TextBox 4"/>
+          <p:cNvSpPr txBox="1"/>
+          <p:nvPr/>
+        </p:nvSpPr>
+        <p:spPr>
+          <a:xfrm>
+            <a:off x="6675120" y="1828800"/>
+            <a:ext cx="2377440" cy="1005840"/>
+          </a:xfrm>
+          <a:prstGeom prst="rect">
+            <a:avLst/>
+          </a:prstGeom>
+          <a:noFill/>
+        </p:spPr>
+        <p:txBody>
+          <a:bodyPr wrap="square">
+            <a:spAutoFit/>
+          </a:bodyPr>
+          <a:lstStyle/>
+          <a:p>
+            <a:pPr>
+              <a:spcAft>
+                <a:spcPts val="0"/>
+              </a:spcAft>
+            </a:pPr>
+            <a:r>
+              <a:rPr sz="3200" b="1">
+                <a:solidFill>
+                  <a:srgbClr val="6CFF5C"/>
+                </a:solidFill>
+                <a:latin typeface="Chakra Petch"/>
+              </a:rPr>
+              <a:t>244</a:t>
+            </a:r>
+          </a:p>
+          <a:p>
+            <a:pPr>
+              <a:spcAft>
+                <a:spcPts val="0"/>
+              </a:spcAft>
+            </a:pPr>
+            <a:r>
+              <a:rPr sz="900" b="0">
                 <a:solidFill>
                   <a:srgbClr val="7D967A"/>
                 </a:solidFill>
                 <a:latin typeface="Consolas"/>
               </a:rPr>
-              <a:t>(VO counts frames not metres; EKF never</a:t>
-            </a:r>
-          </a:p>
-          <a:p>
-            <a:pPr>
-              <a:spcAft>
-                <a:spcPts val="200"/>
-              </a:spcAft>
-            </a:pPr>
-            <a:r>
-              <a:rPr sz="1100">
+              <a:t>FRAMES TRIAGED · 2 SESSIONS</a:t>
+            </a:r>
+          </a:p>
+        </p:txBody>
+      </p:sp>
+      <p:sp>
+        <p:nvSpPr>
+          <p:cNvPr id="6" name="TextBox 5"/>
+          <p:cNvSpPr txBox="1"/>
+          <p:nvPr/>
+        </p:nvSpPr>
+        <p:spPr>
+          <a:xfrm>
+            <a:off x="9052560" y="1828800"/>
+            <a:ext cx="2377440" cy="1005840"/>
+          </a:xfrm>
+          <a:prstGeom prst="rect">
+            <a:avLst/>
+          </a:prstGeom>
+          <a:noFill/>
+        </p:spPr>
+        <p:txBody>
+          <a:bodyPr wrap="square">
+            <a:spAutoFit/>
+          </a:bodyPr>
+          <a:lstStyle/>
+          <a:p>
+            <a:pPr>
+              <a:spcAft>
+                <a:spcPts val="0"/>
+              </a:spcAft>
+            </a:pPr>
+            <a:r>
+              <a:rPr sz="3200" b="1">
+                <a:solidFill>
+                  <a:srgbClr val="6CFF5C"/>
+                </a:solidFill>
+                <a:latin typeface="Chakra Petch"/>
+              </a:rPr>
+              <a:t>99.5%</a:t>
+            </a:r>
+          </a:p>
+          <a:p>
+            <a:pPr>
+              <a:spcAft>
+                <a:spcPts val="0"/>
+              </a:spcAft>
+            </a:pPr>
+            <a:r>
+              <a:rPr sz="900" b="0">
                 <a:solidFill>
                   <a:srgbClr val="7D967A"/>
                 </a:solidFill>
                 <a:latin typeface="Consolas"/>
               </a:rPr>
-              <a:t> sees a real camera measurement)</a:t>
-            </a:r>
-          </a:p>
-          <a:p>
-            <a:pPr>
-              <a:spcAft>
-                <a:spcPts val="200"/>
-              </a:spcAft>
-            </a:pPr>
-            <a:r>
-              <a:rPr sz="1100">
-                <a:solidFill>
-                  <a:srgbClr val="C9DFC2"/>
-                </a:solidFill>
-                <a:latin typeface="Consolas"/>
-              </a:rPr>
-              <a:t/>
-            </a:r>
-          </a:p>
-          <a:p>
-            <a:pPr>
-              <a:spcAft>
-                <a:spcPts val="200"/>
-              </a:spcAft>
-            </a:pPr>
-            <a:r>
-              <a:rPr sz="1100">
-                <a:solidFill>
-                  <a:srgbClr val="C9DFC2"/>
-                </a:solidFill>
-                <a:latin typeface="Consolas"/>
-              </a:rPr>
-              <a:t>phase 1  honest measurement (de-anchor sim)</a:t>
-            </a:r>
-          </a:p>
-          <a:p>
-            <a:pPr>
-              <a:spcAft>
-                <a:spcPts val="200"/>
-              </a:spcAft>
-            </a:pPr>
-            <a:r>
-              <a:rPr sz="1100">
-                <a:solidFill>
-                  <a:srgbClr val="C9DFC2"/>
-                </a:solidFill>
-                <a:latin typeface="Consolas"/>
-              </a:rPr>
-              <a:t>phase 2  keyframe VO</a:t>
-            </a:r>
-          </a:p>
-          <a:p>
-            <a:pPr>
-              <a:spcAft>
-                <a:spcPts val="200"/>
-              </a:spcAft>
-            </a:pPr>
-            <a:r>
-              <a:rPr sz="1100">
-                <a:solidFill>
-                  <a:srgbClr val="FFB454"/>
-                </a:solidFill>
-                <a:latin typeface="Consolas"/>
-              </a:rPr>
-              <a:t>phase 3  metric scale        &lt;- the crux</a:t>
-            </a:r>
-          </a:p>
-          <a:p>
-            <a:pPr>
-              <a:spcAft>
-                <a:spcPts val="200"/>
-              </a:spcAft>
-            </a:pPr>
-            <a:r>
-              <a:rPr sz="1100">
-                <a:solidFill>
-                  <a:srgbClr val="C9DFC2"/>
-                </a:solidFill>
-                <a:latin typeface="Consolas"/>
-              </a:rPr>
-              <a:t>phase 4  real EKF updates</a:t>
-            </a:r>
-          </a:p>
-          <a:p>
-            <a:pPr>
-              <a:spcAft>
-                <a:spcPts val="200"/>
-              </a:spcAft>
-            </a:pPr>
-            <a:r>
-              <a:rPr sz="1100">
-                <a:solidFill>
-                  <a:srgbClr val="C9DFC2"/>
-                </a:solidFill>
-                <a:latin typeface="Consolas"/>
-              </a:rPr>
-              <a:t>phase 5  IMU fusion</a:t>
-            </a:r>
-          </a:p>
-          <a:p>
-            <a:pPr>
-              <a:spcAft>
-                <a:spcPts val="200"/>
-              </a:spcAft>
-            </a:pPr>
-            <a:r>
-              <a:rPr sz="1100">
-                <a:solidFill>
-                  <a:srgbClr val="C9DFC2"/>
-                </a:solidFill>
-                <a:latin typeface="Consolas"/>
-              </a:rPr>
-              <a:t>phase 6  record-replay + hardware ladder</a:t>
+              <a:t>DETECTOR PRECISION</a:t>
+            </a:r>
+          </a:p>
+        </p:txBody>
+      </p:sp>
+      <p:sp>
+        <p:nvSpPr>
+          <p:cNvPr id="7" name="TextBox 6"/>
+          <p:cNvSpPr txBox="1"/>
+          <p:nvPr/>
+        </p:nvSpPr>
+        <p:spPr>
+          <a:xfrm>
+            <a:off x="6675120" y="3017520"/>
+            <a:ext cx="2377440" cy="1005840"/>
+          </a:xfrm>
+          <a:prstGeom prst="rect">
+            <a:avLst/>
+          </a:prstGeom>
+          <a:noFill/>
+        </p:spPr>
+        <p:txBody>
+          <a:bodyPr wrap="square">
+            <a:spAutoFit/>
+          </a:bodyPr>
+          <a:lstStyle/>
+          <a:p>
+            <a:pPr>
+              <a:spcAft>
+                <a:spcPts val="0"/>
+              </a:spcAft>
+            </a:pPr>
+            <a:r>
+              <a:rPr sz="3200" b="1">
+                <a:solidFill>
+                  <a:srgbClr val="6CFF5C"/>
+                </a:solidFill>
+                <a:latin typeface="Chakra Petch"/>
+              </a:rPr>
+              <a:t>198/46</a:t>
+            </a:r>
+          </a:p>
+          <a:p>
+            <a:pPr>
+              <a:spcAft>
+                <a:spcPts val="0"/>
+              </a:spcAft>
+            </a:pPr>
+            <a:r>
+              <a:rPr sz="900" b="0">
+                <a:solidFill>
+                  <a:srgbClr val="7D967A"/>
+                </a:solidFill>
+                <a:latin typeface="Consolas"/>
+              </a:rPr>
+              <a:t>POSITIVES / NEGATIVES</a:t>
+            </a:r>
+          </a:p>
+        </p:txBody>
+      </p:sp>
+      <p:sp>
+        <p:nvSpPr>
+          <p:cNvPr id="8" name="TextBox 7"/>
+          <p:cNvSpPr txBox="1"/>
+          <p:nvPr/>
+        </p:nvSpPr>
+        <p:spPr>
+          <a:xfrm>
+            <a:off x="9052560" y="3017520"/>
+            <a:ext cx="2377440" cy="1005840"/>
+          </a:xfrm>
+          <a:prstGeom prst="rect">
+            <a:avLst/>
+          </a:prstGeom>
+          <a:noFill/>
+        </p:spPr>
+        <p:txBody>
+          <a:bodyPr wrap="square">
+            <a:spAutoFit/>
+          </a:bodyPr>
+          <a:lstStyle/>
+          <a:p>
+            <a:pPr>
+              <a:spcAft>
+                <a:spcPts val="0"/>
+              </a:spcAft>
+            </a:pPr>
+            <a:r>
+              <a:rPr sz="3200" b="1">
+                <a:solidFill>
+                  <a:srgbClr val="5EE6D0"/>
+                </a:solidFill>
+                <a:latin typeface="Chakra Petch"/>
+              </a:rPr>
+              <a:t>0 FP</a:t>
+            </a:r>
+          </a:p>
+          <a:p>
+            <a:pPr>
+              <a:spcAft>
+                <a:spcPts val="0"/>
+              </a:spcAft>
+            </a:pPr>
+            <a:r>
+              <a:rPr sz="900" b="0">
+                <a:solidFill>
+                  <a:srgbClr val="7D967A"/>
+                </a:solidFill>
+                <a:latin typeface="Consolas"/>
+              </a:rPr>
+              <a:t>FALSE POSITIVES · 1 BOX-FIX</a:t>
+            </a:r>
+          </a:p>
+        </p:txBody>
+      </p:sp>
+      <p:sp>
+        <p:nvSpPr>
+          <p:cNvPr id="9" name="TextBox 8"/>
+          <p:cNvSpPr txBox="1"/>
+          <p:nvPr/>
+        </p:nvSpPr>
+        <p:spPr>
+          <a:xfrm>
+            <a:off x="6675120" y="4206240"/>
+            <a:ext cx="4846320" cy="1828800"/>
+          </a:xfrm>
+          <a:prstGeom prst="rect">
+            <a:avLst/>
+          </a:prstGeom>
+          <a:noFill/>
+        </p:spPr>
+        <p:txBody>
+          <a:bodyPr wrap="square">
+            <a:spAutoFit/>
+          </a:bodyPr>
+          <a:lstStyle/>
+          <a:p>
+            <a:pPr>
+              <a:spcAft>
+                <a:spcPts val="600"/>
+              </a:spcAft>
+            </a:pPr>
+            <a:r>
+              <a:rPr sz="1200" b="0">
+                <a:solidFill>
+                  <a:srgbClr val="7D967A"/>
+                </a:solidFill>
+                <a:latin typeface="Consolas"/>
+              </a:rPr>
+              <a:t>Of 198 detector cat-claims: 197 confirmed, 1 box-fix, zero false positives. Fine-tuning waits for ~500 varied positives (40% there); these sessions become the eval set any future model must beat.</a:t>
             </a:r>
           </a:p>
         </p:txBody>
@@ -4648,6 +4565,467 @@
                 </a:solidFill>
                 <a:latin typeface="Consolas"/>
               </a:rPr>
+              <a:t>// 11 · ROADMAP</a:t>
+            </a:r>
+          </a:p>
+        </p:txBody>
+      </p:sp>
+      <p:sp>
+        <p:nvSpPr>
+          <p:cNvPr id="3" name="TextBox 2"/>
+          <p:cNvSpPr txBox="1"/>
+          <p:nvPr/>
+        </p:nvSpPr>
+        <p:spPr>
+          <a:xfrm>
+            <a:off x="640080" y="685800"/>
+            <a:ext cx="10972800" cy="822960"/>
+          </a:xfrm>
+          <a:prstGeom prst="rect">
+            <a:avLst/>
+          </a:prstGeom>
+          <a:noFill/>
+        </p:spPr>
+        <p:txBody>
+          <a:bodyPr wrap="square">
+            <a:spAutoFit/>
+          </a:bodyPr>
+          <a:lstStyle/>
+          <a:p>
+            <a:pPr>
+              <a:spcAft>
+                <a:spcPts val="600"/>
+              </a:spcAft>
+            </a:pPr>
+            <a:r>
+              <a:rPr sz="3400" b="1">
+                <a:solidFill>
+                  <a:srgbClr val="EAFFE6"/>
+                </a:solidFill>
+                <a:latin typeface="Chakra Petch"/>
+              </a:rPr>
+              <a:t>Next sorties + the SLAM campaign</a:t>
+            </a:r>
+          </a:p>
+        </p:txBody>
+      </p:sp>
+      <p:sp>
+        <p:nvSpPr>
+          <p:cNvPr id="4" name="TextBox 3"/>
+          <p:cNvSpPr txBox="1"/>
+          <p:nvPr/>
+        </p:nvSpPr>
+        <p:spPr>
+          <a:xfrm>
+            <a:off x="640080" y="1737360"/>
+            <a:ext cx="5852160" cy="4572000"/>
+          </a:xfrm>
+          <a:prstGeom prst="rect">
+            <a:avLst/>
+          </a:prstGeom>
+          <a:noFill/>
+        </p:spPr>
+        <p:txBody>
+          <a:bodyPr wrap="square">
+            <a:spAutoFit/>
+          </a:bodyPr>
+          <a:lstStyle/>
+          <a:p>
+            <a:pPr>
+              <a:spcAft>
+                <a:spcPts val="1000"/>
+              </a:spcAft>
+            </a:pPr>
+            <a:r>
+              <a:rPr sz="1300" b="1">
+                <a:solidFill>
+                  <a:srgbClr val="EAFFE6"/>
+                </a:solidFill>
+                <a:latin typeface="Consolas"/>
+              </a:rPr>
+              <a:t>▸ Pan-servo search  </a:t>
+            </a:r>
+            <a:r>
+              <a:rPr sz="1300">
+                <a:solidFill>
+                  <a:srgbClr val="7D967A"/>
+                </a:solidFill>
+                <a:latin typeface="Consolas"/>
+              </a:rPr>
+              <a:t>sweep the camera, not the chassis: sharp frames, 3x coverage, zero blur. One servo-sign check away.</a:t>
+            </a:r>
+          </a:p>
+          <a:p>
+            <a:pPr>
+              <a:spcAft>
+                <a:spcPts val="1000"/>
+              </a:spcAft>
+            </a:pPr>
+            <a:r>
+              <a:rPr sz="1300" b="1">
+                <a:solidFill>
+                  <a:srgbClr val="EAFFE6"/>
+                </a:solidFill>
+                <a:latin typeface="Consolas"/>
+              </a:rPr>
+              <a:t>▸ Exposure control  </a:t>
+            </a:r>
+            <a:r>
+              <a:rPr sz="1300">
+                <a:solidFill>
+                  <a:srgbClr val="7D967A"/>
+                </a:solidFill>
+                <a:latin typeface="Consolas"/>
+              </a:rPr>
+              <a:t>shorter shutter to cut rotation blur at the source.</a:t>
+            </a:r>
+          </a:p>
+          <a:p>
+            <a:pPr>
+              <a:spcAft>
+                <a:spcPts val="1000"/>
+              </a:spcAft>
+            </a:pPr>
+            <a:r>
+              <a:rPr sz="1300" b="1">
+                <a:solidFill>
+                  <a:srgbClr val="EAFFE6"/>
+                </a:solidFill>
+                <a:latin typeface="Consolas"/>
+              </a:rPr>
+              <a:t>▸ Lead pursuit  </a:t>
+            </a:r>
+            <a:r>
+              <a:rPr sz="1300">
+                <a:solidFill>
+                  <a:srgbClr val="7D967A"/>
+                </a:solidFill>
+                <a:latin typeface="Consolas"/>
+              </a:rPr>
+              <a:t>centroid velocity prediction, for when the Bengal stops going easy.</a:t>
+            </a:r>
+          </a:p>
+          <a:p>
+            <a:pPr>
+              <a:spcAft>
+                <a:spcPts val="1000"/>
+              </a:spcAft>
+            </a:pPr>
+            <a:r>
+              <a:rPr sz="1300" b="1">
+                <a:solidFill>
+                  <a:srgbClr val="EAFFE6"/>
+                </a:solidFill>
+                <a:latin typeface="Consolas"/>
+              </a:rPr>
+              <a:t>▸ IR kill verification  </a:t>
+            </a:r>
+            <a:r>
+              <a:rPr sz="1300">
+                <a:solidFill>
+                  <a:srgbClr val="7D967A"/>
+                </a:solidFill>
+                <a:latin typeface="Consolas"/>
+              </a:rPr>
+              <a:t>the last unchecked box before unsupervised roaming.</a:t>
+            </a:r>
+          </a:p>
+        </p:txBody>
+      </p:sp>
+      <p:sp>
+        <p:nvSpPr>
+          <p:cNvPr id="5" name="Rectangle 4"/>
+          <p:cNvSpPr/>
+          <p:nvPr/>
+        </p:nvSpPr>
+        <p:spPr>
+          <a:xfrm>
+            <a:off x="6766560" y="1737360"/>
+            <a:ext cx="4846320" cy="3291840"/>
+          </a:xfrm>
+          <a:prstGeom prst="rect">
+            <a:avLst/>
+          </a:prstGeom>
+          <a:solidFill>
+            <a:srgbClr val="0D130C"/>
+          </a:solidFill>
+          <a:ln w="12700">
+            <a:solidFill>
+              <a:srgbClr val="22331F"/>
+            </a:solidFill>
+          </a:ln>
+        </p:spPr>
+        <p:style>
+          <a:lnRef idx="1">
+            <a:schemeClr val="accent1"/>
+          </a:lnRef>
+          <a:fillRef idx="3">
+            <a:schemeClr val="accent1"/>
+          </a:fillRef>
+          <a:effectRef idx="2">
+            <a:schemeClr val="accent1"/>
+          </a:effectRef>
+          <a:fontRef idx="minor">
+            <a:schemeClr val="lt1"/>
+          </a:fontRef>
+        </p:style>
+        <p:txBody>
+          <a:bodyPr rtlCol="0" anchor="ctr" wrap="none" lIns="120000" tIns="90000"/>
+          <a:lstStyle/>
+          <a:p>
+            <a:pPr algn="ctr">
+              <a:spcAft>
+                <a:spcPts val="200"/>
+              </a:spcAft>
+            </a:pPr>
+            <a:r>
+              <a:rPr sz="1100">
+                <a:solidFill>
+                  <a:srgbClr val="3D9A45"/>
+                </a:solidFill>
+                <a:latin typeface="Consolas"/>
+              </a:rPr>
+              <a:t>SLAM CAMPAIGN (separate track)</a:t>
+            </a:r>
+          </a:p>
+          <a:p>
+            <a:pPr>
+              <a:spcAft>
+                <a:spcPts val="200"/>
+              </a:spcAft>
+            </a:pPr>
+            <a:r>
+              <a:rPr sz="1100">
+                <a:solidFill>
+                  <a:srgbClr val="C9DFC2"/>
+                </a:solidFill>
+                <a:latin typeface="Consolas"/>
+              </a:rPr>
+              <a:t/>
+            </a:r>
+          </a:p>
+          <a:p>
+            <a:pPr>
+              <a:spcAft>
+                <a:spcPts val="200"/>
+              </a:spcAft>
+            </a:pPr>
+            <a:r>
+              <a:rPr sz="1100">
+                <a:solidFill>
+                  <a:srgbClr val="7D967A"/>
+                </a:solidFill>
+                <a:latin typeface="Consolas"/>
+              </a:rPr>
+              <a:t>external review: no metric map possible yet</a:t>
+            </a:r>
+          </a:p>
+          <a:p>
+            <a:pPr>
+              <a:spcAft>
+                <a:spcPts val="200"/>
+              </a:spcAft>
+            </a:pPr>
+            <a:r>
+              <a:rPr sz="1100">
+                <a:solidFill>
+                  <a:srgbClr val="7D967A"/>
+                </a:solidFill>
+                <a:latin typeface="Consolas"/>
+              </a:rPr>
+              <a:t>(VO counts frames not metres; EKF never</a:t>
+            </a:r>
+          </a:p>
+          <a:p>
+            <a:pPr>
+              <a:spcAft>
+                <a:spcPts val="200"/>
+              </a:spcAft>
+            </a:pPr>
+            <a:r>
+              <a:rPr sz="1100">
+                <a:solidFill>
+                  <a:srgbClr val="7D967A"/>
+                </a:solidFill>
+                <a:latin typeface="Consolas"/>
+              </a:rPr>
+              <a:t> sees a real camera measurement)</a:t>
+            </a:r>
+          </a:p>
+          <a:p>
+            <a:pPr>
+              <a:spcAft>
+                <a:spcPts val="200"/>
+              </a:spcAft>
+            </a:pPr>
+            <a:r>
+              <a:rPr sz="1100">
+                <a:solidFill>
+                  <a:srgbClr val="C9DFC2"/>
+                </a:solidFill>
+                <a:latin typeface="Consolas"/>
+              </a:rPr>
+              <a:t/>
+            </a:r>
+          </a:p>
+          <a:p>
+            <a:pPr>
+              <a:spcAft>
+                <a:spcPts val="200"/>
+              </a:spcAft>
+            </a:pPr>
+            <a:r>
+              <a:rPr sz="1100">
+                <a:solidFill>
+                  <a:srgbClr val="C9DFC2"/>
+                </a:solidFill>
+                <a:latin typeface="Consolas"/>
+              </a:rPr>
+              <a:t>phase 1  honest measurement (de-anchor sim)</a:t>
+            </a:r>
+          </a:p>
+          <a:p>
+            <a:pPr>
+              <a:spcAft>
+                <a:spcPts val="200"/>
+              </a:spcAft>
+            </a:pPr>
+            <a:r>
+              <a:rPr sz="1100">
+                <a:solidFill>
+                  <a:srgbClr val="C9DFC2"/>
+                </a:solidFill>
+                <a:latin typeface="Consolas"/>
+              </a:rPr>
+              <a:t>phase 2  keyframe VO</a:t>
+            </a:r>
+          </a:p>
+          <a:p>
+            <a:pPr>
+              <a:spcAft>
+                <a:spcPts val="200"/>
+              </a:spcAft>
+            </a:pPr>
+            <a:r>
+              <a:rPr sz="1100">
+                <a:solidFill>
+                  <a:srgbClr val="FFB454"/>
+                </a:solidFill>
+                <a:latin typeface="Consolas"/>
+              </a:rPr>
+              <a:t>phase 3  metric scale        &lt;- the crux</a:t>
+            </a:r>
+          </a:p>
+          <a:p>
+            <a:pPr>
+              <a:spcAft>
+                <a:spcPts val="200"/>
+              </a:spcAft>
+            </a:pPr>
+            <a:r>
+              <a:rPr sz="1100">
+                <a:solidFill>
+                  <a:srgbClr val="C9DFC2"/>
+                </a:solidFill>
+                <a:latin typeface="Consolas"/>
+              </a:rPr>
+              <a:t>phase 4  real EKF updates</a:t>
+            </a:r>
+          </a:p>
+          <a:p>
+            <a:pPr>
+              <a:spcAft>
+                <a:spcPts val="200"/>
+              </a:spcAft>
+            </a:pPr>
+            <a:r>
+              <a:rPr sz="1100">
+                <a:solidFill>
+                  <a:srgbClr val="C9DFC2"/>
+                </a:solidFill>
+                <a:latin typeface="Consolas"/>
+              </a:rPr>
+              <a:t>phase 5  IMU fusion</a:t>
+            </a:r>
+          </a:p>
+          <a:p>
+            <a:pPr>
+              <a:spcAft>
+                <a:spcPts val="200"/>
+              </a:spcAft>
+            </a:pPr>
+            <a:r>
+              <a:rPr sz="1100">
+                <a:solidFill>
+                  <a:srgbClr val="C9DFC2"/>
+                </a:solidFill>
+                <a:latin typeface="Consolas"/>
+              </a:rPr>
+              <a:t>phase 6  record-replay + hardware ladder</a:t>
+            </a:r>
+          </a:p>
+        </p:txBody>
+      </p:sp>
+    </p:spTree>
+  </p:cSld>
+  <p:clrMapOvr>
+    <a:masterClrMapping/>
+  </p:clrMapOvr>
+</p:sld>
+</file>
+
+<file path=ppt/slides/slide14.xml><?xml version="1.0" encoding="utf-8"?>
+<p:sld xmlns:a="http://schemas.openxmlformats.org/drawingml/2006/main" xmlns:p="http://schemas.openxmlformats.org/presentationml/2006/main" xmlns:r="http://schemas.openxmlformats.org/officeDocument/2006/relationships">
+  <p:cSld>
+    <p:bg>
+      <p:bgPr>
+        <a:solidFill>
+          <a:srgbClr val="070B07"/>
+        </a:solidFill>
+        <a:effectLst/>
+      </p:bgPr>
+    </p:bg>
+    <p:spTree>
+      <p:nvGrpSpPr>
+        <p:cNvPr id="1" name=""/>
+        <p:cNvGrpSpPr/>
+        <p:nvPr/>
+      </p:nvGrpSpPr>
+      <p:grpSpPr/>
+      <p:sp>
+        <p:nvSpPr>
+          <p:cNvPr id="2" name="TextBox 1"/>
+          <p:cNvSpPr txBox="1"/>
+          <p:nvPr/>
+        </p:nvSpPr>
+        <p:spPr>
+          <a:xfrm>
+            <a:off x="640080" y="320040"/>
+            <a:ext cx="10972800" cy="365760"/>
+          </a:xfrm>
+          <a:prstGeom prst="rect">
+            <a:avLst/>
+          </a:prstGeom>
+          <a:noFill/>
+        </p:spPr>
+        <p:txBody>
+          <a:bodyPr wrap="square">
+            <a:spAutoFit/>
+          </a:bodyPr>
+          <a:lstStyle/>
+          <a:p>
+            <a:pPr>
+              <a:spcAft>
+                <a:spcPts val="600"/>
+              </a:spcAft>
+            </a:pPr>
+            <a:r>
+              <a:rPr sz="1100" b="0">
+                <a:solidFill>
+                  <a:srgbClr val="3D9A45"/>
+                </a:solidFill>
+                <a:latin typeface="Consolas"/>
+              </a:rPr>
               <a:t>// 12 · END OF TRANSMISSION</a:t>
             </a:r>
           </a:p>
@@ -6104,7 +6482,7 @@
                 </a:solidFill>
                 <a:latin typeface="Consolas"/>
               </a:rPr>
-              <a:t>Not yet — 93% raw precision in the field. Pipeline stands ready.</a:t>
+              <a:t>Not yet — 99.5% precision over 244 triaged frames, 0 false positives. Pipeline ready.</a:t>
             </a:r>
           </a:p>
         </p:txBody>

</xml_diff>

<commit_message>
Confusion matrix: precision 100%, recall 89.6% (found the FN quadrant)
Reviewing the good-on-empty frames revealed the missing quadrant: 23 frames
where the reviewer pressed 'good' but the detector drew no box are all
verified cats -> false negatives (the detector missed them), not true
negatives. Corrected matrix over 244 reviewed frames:
  TP 198 · FP 0 · FN 23 · TN 23  ->  precision 100%, recall 89.6%, F1 94.5%.

dataset_stats.py now computes the full 2x2 (empty+nocat=TN, empty+good/fix=
missed cat=FN) and prints the matrix + P/R/F1. Both decks gain a confusion-
matrix slide and corrected precision/recall stats.

Two findings flagged (CLAUDE.md): the 23 misses are mislabeled as negatives
(training poison — re-box before fine-tune), and review.py's 'good' is a
trap on no-box frames (should hide it or add an explicit Missed action).

Co-Authored-By: Claude Opus 4.8 (1M context) <noreply@anthropic.com>
</commit_message>
<xml_diff>
--- a/docs/catchaser_presentation.pptx
+++ b/docs/catchaser_presentation.pptx
@@ -19,6 +19,7 @@
     <p:sldId id="267" r:id="rId18"/>
     <p:sldId id="268" r:id="rId19"/>
     <p:sldId id="269" r:id="rId20"/>
+    <p:sldId id="270" r:id="rId21"/>
   </p:sldIdLst>
   <p:sldSz cx="12191695" cy="6858000" type="screen4x3"/>
   <p:notesSz cx="6858000" cy="9144000"/>
@@ -4335,7 +4336,7 @@
                 </a:solidFill>
                 <a:latin typeface="Chakra Petch"/>
               </a:rPr>
-              <a:t>99.5%</a:t>
+              <a:t>100%</a:t>
             </a:r>
           </a:p>
           <a:p>
@@ -4351,7 +4352,7 @@
                 </a:solidFill>
                 <a:latin typeface="Consolas"/>
               </a:rPr>
-              <a:t>DETECTOR PRECISION</a:t>
+              <a:t>PRECISION · 0 FP</a:t>
             </a:r>
           </a:p>
         </p:txBody>
@@ -4386,11 +4387,11 @@
             <a:r>
               <a:rPr sz="3200" b="1">
                 <a:solidFill>
-                  <a:srgbClr val="6CFF5C"/>
+                  <a:srgbClr val="FFB454"/>
                 </a:solidFill>
                 <a:latin typeface="Chakra Petch"/>
               </a:rPr>
-              <a:t>198/46</a:t>
+              <a:t>90%</a:t>
             </a:r>
           </a:p>
           <a:p>
@@ -4406,7 +4407,7 @@
                 </a:solidFill>
                 <a:latin typeface="Consolas"/>
               </a:rPr>
-              <a:t>POSITIVES / NEGATIVES</a:t>
+              <a:t>RECALL · 23 MISSES</a:t>
             </a:r>
           </a:p>
         </p:txBody>
@@ -4445,7 +4446,7 @@
                 </a:solidFill>
                 <a:latin typeface="Chakra Petch"/>
               </a:rPr>
-              <a:t>0 FP</a:t>
+              <a:t>94.5%</a:t>
             </a:r>
           </a:p>
           <a:p>
@@ -4461,7 +4462,7 @@
                 </a:solidFill>
                 <a:latin typeface="Consolas"/>
               </a:rPr>
-              <a:t>FALSE POSITIVES · 1 BOX-FIX</a:t>
+              <a:t>F1 SCORE</a:t>
             </a:r>
           </a:p>
         </p:txBody>
@@ -4500,7 +4501,7 @@
                 </a:solidFill>
                 <a:latin typeface="Consolas"/>
               </a:rPr>
-              <a:t>Of 198 detector cat-claims: 197 confirmed, 1 box-fix, zero false positives. Fine-tuning waits for ~500 varied positives (40% there); these sessions become the eval set any future model must beat.</a:t>
+              <a:t>Triaging by thumb also measures the detector — every tap is a confusion-matrix cell (next slide). It surfaced 23 missed cats hiding as negatives. Fine-tuning waits for ~500 varied positives; these become the eval set to beat.</a:t>
             </a:r>
           </a:p>
         </p:txBody>
@@ -4565,7 +4566,7 @@
                 </a:solidFill>
                 <a:latin typeface="Consolas"/>
               </a:rPr>
-              <a:t>// 11 · ROADMAP</a:t>
+              <a:t>// 10B · EVALUATION · CONFUSION MATRIX · 244 REVIEWED FRAMES</a:t>
             </a:r>
           </a:p>
         </p:txBody>
@@ -4604,134 +4605,251 @@
                 </a:solidFill>
                 <a:latin typeface="Chakra Petch"/>
               </a:rPr>
-              <a:t>Next sorties + the SLAM campaign</a:t>
-            </a:r>
-          </a:p>
-        </p:txBody>
-      </p:sp>
-      <p:sp>
-        <p:nvSpPr>
-          <p:cNvPr id="4" name="TextBox 3"/>
-          <p:cNvSpPr txBox="1"/>
+              <a:t>Precision 100% · Recall 90%</a:t>
+            </a:r>
+          </a:p>
+        </p:txBody>
+      </p:sp>
+      <p:graphicFrame>
+        <p:nvGraphicFramePr>
+          <p:cNvPr id="4" name="Table 3"/>
+          <p:cNvGraphicFramePr>
+            <a:graphicFrameLocks noGrp="1"/>
+          </p:cNvGraphicFramePr>
           <p:nvPr/>
-        </p:nvSpPr>
-        <p:spPr>
-          <a:xfrm>
-            <a:off x="640080" y="1737360"/>
-            <a:ext cx="5852160" cy="4572000"/>
-          </a:xfrm>
-          <a:prstGeom prst="rect">
-            <a:avLst/>
-          </a:prstGeom>
-          <a:noFill/>
-        </p:spPr>
-        <p:txBody>
-          <a:bodyPr wrap="square">
-            <a:spAutoFit/>
-          </a:bodyPr>
-          <a:lstStyle/>
-          <a:p>
-            <a:pPr>
-              <a:spcAft>
-                <a:spcPts val="1000"/>
-              </a:spcAft>
-            </a:pPr>
-            <a:r>
-              <a:rPr sz="1300" b="1">
-                <a:solidFill>
-                  <a:srgbClr val="EAFFE6"/>
-                </a:solidFill>
-                <a:latin typeface="Consolas"/>
-              </a:rPr>
-              <a:t>▸ Pan-servo search  </a:t>
-            </a:r>
-            <a:r>
-              <a:rPr sz="1300">
-                <a:solidFill>
-                  <a:srgbClr val="7D967A"/>
-                </a:solidFill>
-                <a:latin typeface="Consolas"/>
-              </a:rPr>
-              <a:t>sweep the camera, not the chassis: sharp frames, 3x coverage, zero blur. One servo-sign check away.</a:t>
-            </a:r>
-          </a:p>
-          <a:p>
-            <a:pPr>
-              <a:spcAft>
-                <a:spcPts val="1000"/>
-              </a:spcAft>
-            </a:pPr>
-            <a:r>
-              <a:rPr sz="1300" b="1">
-                <a:solidFill>
-                  <a:srgbClr val="EAFFE6"/>
-                </a:solidFill>
-                <a:latin typeface="Consolas"/>
-              </a:rPr>
-              <a:t>▸ Exposure control  </a:t>
-            </a:r>
-            <a:r>
-              <a:rPr sz="1300">
-                <a:solidFill>
-                  <a:srgbClr val="7D967A"/>
-                </a:solidFill>
-                <a:latin typeface="Consolas"/>
-              </a:rPr>
-              <a:t>shorter shutter to cut rotation blur at the source.</a:t>
-            </a:r>
-          </a:p>
-          <a:p>
-            <a:pPr>
-              <a:spcAft>
-                <a:spcPts val="1000"/>
-              </a:spcAft>
-            </a:pPr>
-            <a:r>
-              <a:rPr sz="1300" b="1">
-                <a:solidFill>
-                  <a:srgbClr val="EAFFE6"/>
-                </a:solidFill>
-                <a:latin typeface="Consolas"/>
-              </a:rPr>
-              <a:t>▸ Lead pursuit  </a:t>
-            </a:r>
-            <a:r>
-              <a:rPr sz="1300">
-                <a:solidFill>
-                  <a:srgbClr val="7D967A"/>
-                </a:solidFill>
-                <a:latin typeface="Consolas"/>
-              </a:rPr>
-              <a:t>centroid velocity prediction, for when the Bengal stops going easy.</a:t>
-            </a:r>
-          </a:p>
-          <a:p>
-            <a:pPr>
-              <a:spcAft>
-                <a:spcPts val="1000"/>
-              </a:spcAft>
-            </a:pPr>
-            <a:r>
-              <a:rPr sz="1300" b="1">
-                <a:solidFill>
-                  <a:srgbClr val="EAFFE6"/>
-                </a:solidFill>
-                <a:latin typeface="Consolas"/>
-              </a:rPr>
-              <a:t>▸ IR kill verification  </a:t>
-            </a:r>
-            <a:r>
-              <a:rPr sz="1300">
-                <a:solidFill>
-                  <a:srgbClr val="7D967A"/>
-                </a:solidFill>
-                <a:latin typeface="Consolas"/>
-              </a:rPr>
-              <a:t>the last unchecked box before unsupervised roaming.</a:t>
-            </a:r>
-          </a:p>
-        </p:txBody>
-      </p:sp>
+        </p:nvGraphicFramePr>
+        <p:xfrm>
+          <a:off x="640080" y="1737360"/>
+          <a:ext cx="5486400" cy="3108960"/>
+        </p:xfrm>
+        <a:graphic>
+          <a:graphicData uri="http://schemas.openxmlformats.org/drawingml/2006/table">
+            <a:tbl>
+              <a:tblPr firstRow="1" bandRow="1">
+                <a:tableStyleId>{5C22544A-7EE6-4342-B048-85BDC9FD1C3A}</a:tableStyleId>
+              </a:tblPr>
+              <a:tblGrid>
+                <a:gridCol w="1828800"/>
+                <a:gridCol w="1828800"/>
+                <a:gridCol w="1828800"/>
+              </a:tblGrid>
+              <a:tr h="1036320">
+                <a:tc>
+                  <a:txBody>
+                    <a:bodyPr/>
+                    <a:lstStyle/>
+                    <a:p>
+                      <a:pPr algn="ctr"/>
+                      <a:r>
+                        <a:rPr sz="1100" b="0">
+                          <a:solidFill>
+                            <a:srgbClr val="3D9A45"/>
+                          </a:solidFill>
+                          <a:latin typeface="Consolas"/>
+                        </a:rPr>
+                        <a:t/>
+                      </a:r>
+                    </a:p>
+                  </a:txBody>
+                  <a:tcPr marT="30000" marB="30000">
+                    <a:solidFill>
+                      <a:srgbClr val="0D130C"/>
+                    </a:solidFill>
+                  </a:tcPr>
+                </a:tc>
+                <a:tc>
+                  <a:txBody>
+                    <a:bodyPr/>
+                    <a:lstStyle/>
+                    <a:p>
+                      <a:pPr algn="ctr"/>
+                      <a:r>
+                        <a:rPr sz="1100" b="0">
+                          <a:solidFill>
+                            <a:srgbClr val="3D9A45"/>
+                          </a:solidFill>
+                          <a:latin typeface="Consolas"/>
+                        </a:rPr>
+                        <a:t>actual: CAT</a:t>
+                      </a:r>
+                    </a:p>
+                  </a:txBody>
+                  <a:tcPr marT="30000" marB="30000">
+                    <a:solidFill>
+                      <a:srgbClr val="0D130C"/>
+                    </a:solidFill>
+                  </a:tcPr>
+                </a:tc>
+                <a:tc>
+                  <a:txBody>
+                    <a:bodyPr/>
+                    <a:lstStyle/>
+                    <a:p>
+                      <a:pPr algn="ctr"/>
+                      <a:r>
+                        <a:rPr sz="1100" b="0">
+                          <a:solidFill>
+                            <a:srgbClr val="3D9A45"/>
+                          </a:solidFill>
+                          <a:latin typeface="Consolas"/>
+                        </a:rPr>
+                        <a:t>actual: NO CAT</a:t>
+                      </a:r>
+                    </a:p>
+                  </a:txBody>
+                  <a:tcPr marT="30000" marB="30000">
+                    <a:solidFill>
+                      <a:srgbClr val="0D130C"/>
+                    </a:solidFill>
+                  </a:tcPr>
+                </a:tc>
+              </a:tr>
+              <a:tr h="1036320">
+                <a:tc>
+                  <a:txBody>
+                    <a:bodyPr/>
+                    <a:lstStyle/>
+                    <a:p>
+                      <a:pPr algn="ctr"/>
+                      <a:r>
+                        <a:rPr sz="1100" b="0">
+                          <a:solidFill>
+                            <a:srgbClr val="3D9A45"/>
+                          </a:solidFill>
+                          <a:latin typeface="Consolas"/>
+                        </a:rPr>
+                        <a:t>pred: CAT</a:t>
+                      </a:r>
+                    </a:p>
+                  </a:txBody>
+                  <a:tcPr marT="30000" marB="30000">
+                    <a:solidFill>
+                      <a:srgbClr val="0D130C"/>
+                    </a:solidFill>
+                  </a:tcPr>
+                </a:tc>
+                <a:tc>
+                  <a:txBody>
+                    <a:bodyPr/>
+                    <a:lstStyle/>
+                    <a:p>
+                      <a:pPr algn="ctr"/>
+                      <a:r>
+                        <a:rPr sz="1800" b="1">
+                          <a:solidFill>
+                            <a:srgbClr val="6CFF5C"/>
+                          </a:solidFill>
+                          <a:latin typeface="Consolas"/>
+                        </a:rPr>
+                        <a:t>TP  198</a:t>
+                      </a:r>
+                    </a:p>
+                  </a:txBody>
+                  <a:tcPr marT="30000" marB="30000">
+                    <a:solidFill>
+                      <a:srgbClr val="0D130C"/>
+                    </a:solidFill>
+                  </a:tcPr>
+                </a:tc>
+                <a:tc>
+                  <a:txBody>
+                    <a:bodyPr/>
+                    <a:lstStyle/>
+                    <a:p>
+                      <a:pPr algn="ctr"/>
+                      <a:r>
+                        <a:rPr sz="1800" b="1">
+                          <a:solidFill>
+                            <a:srgbClr val="7D967A"/>
+                          </a:solidFill>
+                          <a:latin typeface="Consolas"/>
+                        </a:rPr>
+                        <a:t>FP  0</a:t>
+                      </a:r>
+                    </a:p>
+                  </a:txBody>
+                  <a:tcPr marT="30000" marB="30000">
+                    <a:solidFill>
+                      <a:srgbClr val="0D130C"/>
+                    </a:solidFill>
+                  </a:tcPr>
+                </a:tc>
+              </a:tr>
+              <a:tr h="1036320">
+                <a:tc>
+                  <a:txBody>
+                    <a:bodyPr/>
+                    <a:lstStyle/>
+                    <a:p>
+                      <a:pPr algn="ctr"/>
+                      <a:r>
+                        <a:rPr sz="1100" b="0">
+                          <a:solidFill>
+                            <a:srgbClr val="3D9A45"/>
+                          </a:solidFill>
+                          <a:latin typeface="Consolas"/>
+                        </a:rPr>
+                        <a:t>pred: NO CAT</a:t>
+                      </a:r>
+                    </a:p>
+                  </a:txBody>
+                  <a:tcPr marT="30000" marB="30000">
+                    <a:solidFill>
+                      <a:srgbClr val="0D130C"/>
+                    </a:solidFill>
+                  </a:tcPr>
+                </a:tc>
+                <a:tc>
+                  <a:txBody>
+                    <a:bodyPr/>
+                    <a:lstStyle/>
+                    <a:p>
+                      <a:pPr algn="ctr"/>
+                      <a:r>
+                        <a:rPr sz="1800" b="1">
+                          <a:solidFill>
+                            <a:srgbClr val="FFB454"/>
+                          </a:solidFill>
+                          <a:latin typeface="Consolas"/>
+                        </a:rPr>
+                        <a:t>FN  23</a:t>
+                      </a:r>
+                    </a:p>
+                  </a:txBody>
+                  <a:tcPr marT="30000" marB="30000">
+                    <a:solidFill>
+                      <a:srgbClr val="0D130C"/>
+                    </a:solidFill>
+                  </a:tcPr>
+                </a:tc>
+                <a:tc>
+                  <a:txBody>
+                    <a:bodyPr/>
+                    <a:lstStyle/>
+                    <a:p>
+                      <a:pPr algn="ctr"/>
+                      <a:r>
+                        <a:rPr sz="1800" b="1">
+                          <a:solidFill>
+                            <a:srgbClr val="3D9A45"/>
+                          </a:solidFill>
+                          <a:latin typeface="Consolas"/>
+                        </a:rPr>
+                        <a:t>TN  23</a:t>
+                      </a:r>
+                    </a:p>
+                  </a:txBody>
+                  <a:tcPr marT="30000" marB="30000">
+                    <a:solidFill>
+                      <a:srgbClr val="0D130C"/>
+                    </a:solidFill>
+                  </a:tcPr>
+                </a:tc>
+              </a:tr>
+            </a:tbl>
+          </a:graphicData>
+        </a:graphic>
+      </p:graphicFrame>
       <p:sp>
         <p:nvSpPr>
           <p:cNvPr id="5" name="Rectangle 4"/>
@@ -4740,8 +4858,8 @@
         </p:nvSpPr>
         <p:spPr>
           <a:xfrm>
-            <a:off x="6766560" y="1737360"/>
-            <a:ext cx="4846320" cy="3291840"/>
+            <a:off x="6400800" y="1737360"/>
+            <a:ext cx="5212080" cy="3291840"/>
           </a:xfrm>
           <a:prstGeom prst="rect">
             <a:avLst/>
@@ -4779,23 +4897,23 @@
               </a:spcAft>
             </a:pPr>
             <a:r>
-              <a:rPr sz="1100">
+              <a:rPr sz="1200">
                 <a:solidFill>
                   <a:srgbClr val="3D9A45"/>
                 </a:solidFill>
                 <a:latin typeface="Consolas"/>
               </a:rPr>
-              <a:t>SLAM CAMPAIGN (separate track)</a:t>
-            </a:r>
-          </a:p>
-          <a:p>
-            <a:pPr>
-              <a:spcAft>
-                <a:spcPts val="200"/>
-              </a:spcAft>
-            </a:pPr>
-            <a:r>
-              <a:rPr sz="1100">
+              <a:t>METRICS</a:t>
+            </a:r>
+          </a:p>
+          <a:p>
+            <a:pPr>
+              <a:spcAft>
+                <a:spcPts val="200"/>
+              </a:spcAft>
+            </a:pPr>
+            <a:r>
+              <a:rPr sz="1200">
                 <a:solidFill>
                   <a:srgbClr val="C9DFC2"/>
                 </a:solidFill>
@@ -4811,55 +4929,135 @@
               </a:spcAft>
             </a:pPr>
             <a:r>
-              <a:rPr sz="1100">
+              <a:rPr sz="1200">
+                <a:solidFill>
+                  <a:srgbClr val="6CFF5C"/>
+                </a:solidFill>
+                <a:latin typeface="Consolas"/>
+              </a:rPr>
+              <a:t>precision   198/198  =  100.0%</a:t>
+            </a:r>
+          </a:p>
+          <a:p>
+            <a:pPr>
+              <a:spcAft>
+                <a:spcPts val="200"/>
+              </a:spcAft>
+            </a:pPr>
+            <a:r>
+              <a:rPr sz="1200">
+                <a:solidFill>
+                  <a:srgbClr val="FFB454"/>
+                </a:solidFill>
+                <a:latin typeface="Consolas"/>
+              </a:rPr>
+              <a:t>recall      198/221  =   89.6%</a:t>
+            </a:r>
+          </a:p>
+          <a:p>
+            <a:pPr>
+              <a:spcAft>
+                <a:spcPts val="200"/>
+              </a:spcAft>
+            </a:pPr>
+            <a:r>
+              <a:rPr sz="1200">
+                <a:solidFill>
+                  <a:srgbClr val="C9DFC2"/>
+                </a:solidFill>
+                <a:latin typeface="Consolas"/>
+              </a:rPr>
+              <a:t>F1                   =   94.5%</a:t>
+            </a:r>
+          </a:p>
+          <a:p>
+            <a:pPr>
+              <a:spcAft>
+                <a:spcPts val="200"/>
+              </a:spcAft>
+            </a:pPr>
+            <a:r>
+              <a:rPr sz="1200">
+                <a:solidFill>
+                  <a:srgbClr val="C9DFC2"/>
+                </a:solidFill>
+                <a:latin typeface="Consolas"/>
+              </a:rPr>
+              <a:t>accuracy    221/244  =   90.6%</a:t>
+            </a:r>
+          </a:p>
+          <a:p>
+            <a:pPr>
+              <a:spcAft>
+                <a:spcPts val="200"/>
+              </a:spcAft>
+            </a:pPr>
+            <a:r>
+              <a:rPr sz="1200">
+                <a:solidFill>
+                  <a:srgbClr val="C9DFC2"/>
+                </a:solidFill>
+                <a:latin typeface="Consolas"/>
+              </a:rPr>
+              <a:t/>
+            </a:r>
+          </a:p>
+          <a:p>
+            <a:pPr>
+              <a:spcAft>
+                <a:spcPts val="200"/>
+              </a:spcAft>
+            </a:pPr>
+            <a:r>
+              <a:rPr sz="1200">
                 <a:solidFill>
                   <a:srgbClr val="7D967A"/>
                 </a:solidFill>
                 <a:latin typeface="Consolas"/>
               </a:rPr>
-              <a:t>external review: no metric map possible yet</a:t>
-            </a:r>
-          </a:p>
-          <a:p>
-            <a:pPr>
-              <a:spcAft>
-                <a:spcPts val="200"/>
-              </a:spcAft>
-            </a:pPr>
-            <a:r>
-              <a:rPr sz="1100">
+              <a:t>0 false positives — the 0.50 threshold</a:t>
+            </a:r>
+          </a:p>
+          <a:p>
+            <a:pPr>
+              <a:spcAft>
+                <a:spcPts val="200"/>
+              </a:spcAft>
+            </a:pPr>
+            <a:r>
+              <a:rPr sz="1200">
                 <a:solidFill>
                   <a:srgbClr val="7D967A"/>
                 </a:solidFill>
                 <a:latin typeface="Consolas"/>
               </a:rPr>
-              <a:t>(VO counts frames not metres; EKF never</a:t>
-            </a:r>
-          </a:p>
-          <a:p>
-            <a:pPr>
-              <a:spcAft>
-                <a:spcPts val="200"/>
-              </a:spcAft>
-            </a:pPr>
-            <a:r>
-              <a:rPr sz="1100">
+              <a:t>earns its keep. ~10% misses, all hard:</a:t>
+            </a:r>
+          </a:p>
+          <a:p>
+            <a:pPr>
+              <a:spcAft>
+                <a:spcPts val="200"/>
+              </a:spcAft>
+            </a:pPr>
+            <a:r>
+              <a:rPr sz="1200">
                 <a:solidFill>
                   <a:srgbClr val="7D967A"/>
                 </a:solidFill>
                 <a:latin typeface="Consolas"/>
               </a:rPr>
-              <a:t> sees a real camera measurement)</a:t>
-            </a:r>
-          </a:p>
-          <a:p>
-            <a:pPr>
-              <a:spcAft>
-                <a:spcPts val="200"/>
-              </a:spcAft>
-            </a:pPr>
-            <a:r>
-              <a:rPr sz="1100">
+              <a:t>blur, close-ups, dark-under-furniture.</a:t>
+            </a:r>
+          </a:p>
+          <a:p>
+            <a:pPr>
+              <a:spcAft>
+                <a:spcPts val="200"/>
+              </a:spcAft>
+            </a:pPr>
+            <a:r>
+              <a:rPr sz="1200">
                 <a:solidFill>
                   <a:srgbClr val="C9DFC2"/>
                 </a:solidFill>
@@ -4875,93 +5073,29 @@
               </a:spcAft>
             </a:pPr>
             <a:r>
-              <a:rPr sz="1100">
-                <a:solidFill>
-                  <a:srgbClr val="C9DFC2"/>
-                </a:solidFill>
-                <a:latin typeface="Consolas"/>
-              </a:rPr>
-              <a:t>phase 1  honest measurement (de-anchor sim)</a:t>
-            </a:r>
-          </a:p>
-          <a:p>
-            <a:pPr>
-              <a:spcAft>
-                <a:spcPts val="200"/>
-              </a:spcAft>
-            </a:pPr>
-            <a:r>
-              <a:rPr sz="1100">
-                <a:solidFill>
-                  <a:srgbClr val="C9DFC2"/>
-                </a:solidFill>
-                <a:latin typeface="Consolas"/>
-              </a:rPr>
-              <a:t>phase 2  keyframe VO</a:t>
-            </a:r>
-          </a:p>
-          <a:p>
-            <a:pPr>
-              <a:spcAft>
-                <a:spcPts val="200"/>
-              </a:spcAft>
-            </a:pPr>
-            <a:r>
-              <a:rPr sz="1100">
+              <a:rPr sz="1200">
                 <a:solidFill>
                   <a:srgbClr val="FFB454"/>
                 </a:solidFill>
                 <a:latin typeface="Consolas"/>
               </a:rPr>
-              <a:t>phase 3  metric scale        &lt;- the crux</a:t>
-            </a:r>
-          </a:p>
-          <a:p>
-            <a:pPr>
-              <a:spcAft>
-                <a:spcPts val="200"/>
-              </a:spcAft>
-            </a:pPr>
-            <a:r>
-              <a:rPr sz="1100">
-                <a:solidFill>
-                  <a:srgbClr val="C9DFC2"/>
-                </a:solidFill>
-                <a:latin typeface="Consolas"/>
-              </a:rPr>
-              <a:t>phase 4  real EKF updates</a:t>
-            </a:r>
-          </a:p>
-          <a:p>
-            <a:pPr>
-              <a:spcAft>
-                <a:spcPts val="200"/>
-              </a:spcAft>
-            </a:pPr>
-            <a:r>
-              <a:rPr sz="1100">
-                <a:solidFill>
-                  <a:srgbClr val="C9DFC2"/>
-                </a:solidFill>
-                <a:latin typeface="Consolas"/>
-              </a:rPr>
-              <a:t>phase 5  IMU fusion</a:t>
-            </a:r>
-          </a:p>
-          <a:p>
-            <a:pPr>
-              <a:spcAft>
-                <a:spcPts val="200"/>
-              </a:spcAft>
-            </a:pPr>
-            <a:r>
-              <a:rPr sz="1100">
-                <a:solidFill>
-                  <a:srgbClr val="C9DFC2"/>
-                </a:solidFill>
-                <a:latin typeface="Consolas"/>
-              </a:rPr>
-              <a:t>phase 6  record-replay + hardware ladder</a:t>
+              <a:t>finding: the 23 misses were mislabeled</a:t>
+            </a:r>
+          </a:p>
+          <a:p>
+            <a:pPr>
+              <a:spcAft>
+                <a:spcPts val="200"/>
+              </a:spcAft>
+            </a:pPr>
+            <a:r>
+              <a:rPr sz="1200">
+                <a:solidFill>
+                  <a:srgbClr val="FFB454"/>
+                </a:solidFill>
+                <a:latin typeface="Consolas"/>
+              </a:rPr>
+              <a:t>as negatives — re-box before fine-tune.</a:t>
             </a:r>
           </a:p>
         </p:txBody>
@@ -4975,6 +5109,467 @@
 </file>
 
 <file path=ppt/slides/slide14.xml><?xml version="1.0" encoding="utf-8"?>
+<p:sld xmlns:a="http://schemas.openxmlformats.org/drawingml/2006/main" xmlns:p="http://schemas.openxmlformats.org/presentationml/2006/main" xmlns:r="http://schemas.openxmlformats.org/officeDocument/2006/relationships">
+  <p:cSld>
+    <p:bg>
+      <p:bgPr>
+        <a:solidFill>
+          <a:srgbClr val="070B07"/>
+        </a:solidFill>
+        <a:effectLst/>
+      </p:bgPr>
+    </p:bg>
+    <p:spTree>
+      <p:nvGrpSpPr>
+        <p:cNvPr id="1" name=""/>
+        <p:cNvGrpSpPr/>
+        <p:nvPr/>
+      </p:nvGrpSpPr>
+      <p:grpSpPr/>
+      <p:sp>
+        <p:nvSpPr>
+          <p:cNvPr id="2" name="TextBox 1"/>
+          <p:cNvSpPr txBox="1"/>
+          <p:nvPr/>
+        </p:nvSpPr>
+        <p:spPr>
+          <a:xfrm>
+            <a:off x="640080" y="320040"/>
+            <a:ext cx="10972800" cy="365760"/>
+          </a:xfrm>
+          <a:prstGeom prst="rect">
+            <a:avLst/>
+          </a:prstGeom>
+          <a:noFill/>
+        </p:spPr>
+        <p:txBody>
+          <a:bodyPr wrap="square">
+            <a:spAutoFit/>
+          </a:bodyPr>
+          <a:lstStyle/>
+          <a:p>
+            <a:pPr>
+              <a:spcAft>
+                <a:spcPts val="600"/>
+              </a:spcAft>
+            </a:pPr>
+            <a:r>
+              <a:rPr sz="1100" b="0">
+                <a:solidFill>
+                  <a:srgbClr val="3D9A45"/>
+                </a:solidFill>
+                <a:latin typeface="Consolas"/>
+              </a:rPr>
+              <a:t>// 11 · ROADMAP</a:t>
+            </a:r>
+          </a:p>
+        </p:txBody>
+      </p:sp>
+      <p:sp>
+        <p:nvSpPr>
+          <p:cNvPr id="3" name="TextBox 2"/>
+          <p:cNvSpPr txBox="1"/>
+          <p:nvPr/>
+        </p:nvSpPr>
+        <p:spPr>
+          <a:xfrm>
+            <a:off x="640080" y="685800"/>
+            <a:ext cx="10972800" cy="822960"/>
+          </a:xfrm>
+          <a:prstGeom prst="rect">
+            <a:avLst/>
+          </a:prstGeom>
+          <a:noFill/>
+        </p:spPr>
+        <p:txBody>
+          <a:bodyPr wrap="square">
+            <a:spAutoFit/>
+          </a:bodyPr>
+          <a:lstStyle/>
+          <a:p>
+            <a:pPr>
+              <a:spcAft>
+                <a:spcPts val="600"/>
+              </a:spcAft>
+            </a:pPr>
+            <a:r>
+              <a:rPr sz="3400" b="1">
+                <a:solidFill>
+                  <a:srgbClr val="EAFFE6"/>
+                </a:solidFill>
+                <a:latin typeface="Chakra Petch"/>
+              </a:rPr>
+              <a:t>Next sorties + the SLAM campaign</a:t>
+            </a:r>
+          </a:p>
+        </p:txBody>
+      </p:sp>
+      <p:sp>
+        <p:nvSpPr>
+          <p:cNvPr id="4" name="TextBox 3"/>
+          <p:cNvSpPr txBox="1"/>
+          <p:nvPr/>
+        </p:nvSpPr>
+        <p:spPr>
+          <a:xfrm>
+            <a:off x="640080" y="1737360"/>
+            <a:ext cx="5852160" cy="4572000"/>
+          </a:xfrm>
+          <a:prstGeom prst="rect">
+            <a:avLst/>
+          </a:prstGeom>
+          <a:noFill/>
+        </p:spPr>
+        <p:txBody>
+          <a:bodyPr wrap="square">
+            <a:spAutoFit/>
+          </a:bodyPr>
+          <a:lstStyle/>
+          <a:p>
+            <a:pPr>
+              <a:spcAft>
+                <a:spcPts val="1000"/>
+              </a:spcAft>
+            </a:pPr>
+            <a:r>
+              <a:rPr sz="1300" b="1">
+                <a:solidFill>
+                  <a:srgbClr val="EAFFE6"/>
+                </a:solidFill>
+                <a:latin typeface="Consolas"/>
+              </a:rPr>
+              <a:t>▸ Pan-servo search  </a:t>
+            </a:r>
+            <a:r>
+              <a:rPr sz="1300">
+                <a:solidFill>
+                  <a:srgbClr val="7D967A"/>
+                </a:solidFill>
+                <a:latin typeface="Consolas"/>
+              </a:rPr>
+              <a:t>sweep the camera, not the chassis: sharp frames, 3x coverage, zero blur. One servo-sign check away.</a:t>
+            </a:r>
+          </a:p>
+          <a:p>
+            <a:pPr>
+              <a:spcAft>
+                <a:spcPts val="1000"/>
+              </a:spcAft>
+            </a:pPr>
+            <a:r>
+              <a:rPr sz="1300" b="1">
+                <a:solidFill>
+                  <a:srgbClr val="EAFFE6"/>
+                </a:solidFill>
+                <a:latin typeface="Consolas"/>
+              </a:rPr>
+              <a:t>▸ Exposure control  </a:t>
+            </a:r>
+            <a:r>
+              <a:rPr sz="1300">
+                <a:solidFill>
+                  <a:srgbClr val="7D967A"/>
+                </a:solidFill>
+                <a:latin typeface="Consolas"/>
+              </a:rPr>
+              <a:t>shorter shutter to cut rotation blur at the source.</a:t>
+            </a:r>
+          </a:p>
+          <a:p>
+            <a:pPr>
+              <a:spcAft>
+                <a:spcPts val="1000"/>
+              </a:spcAft>
+            </a:pPr>
+            <a:r>
+              <a:rPr sz="1300" b="1">
+                <a:solidFill>
+                  <a:srgbClr val="EAFFE6"/>
+                </a:solidFill>
+                <a:latin typeface="Consolas"/>
+              </a:rPr>
+              <a:t>▸ Lead pursuit  </a:t>
+            </a:r>
+            <a:r>
+              <a:rPr sz="1300">
+                <a:solidFill>
+                  <a:srgbClr val="7D967A"/>
+                </a:solidFill>
+                <a:latin typeface="Consolas"/>
+              </a:rPr>
+              <a:t>centroid velocity prediction, for when the Bengal stops going easy.</a:t>
+            </a:r>
+          </a:p>
+          <a:p>
+            <a:pPr>
+              <a:spcAft>
+                <a:spcPts val="1000"/>
+              </a:spcAft>
+            </a:pPr>
+            <a:r>
+              <a:rPr sz="1300" b="1">
+                <a:solidFill>
+                  <a:srgbClr val="EAFFE6"/>
+                </a:solidFill>
+                <a:latin typeface="Consolas"/>
+              </a:rPr>
+              <a:t>▸ IR kill verification  </a:t>
+            </a:r>
+            <a:r>
+              <a:rPr sz="1300">
+                <a:solidFill>
+                  <a:srgbClr val="7D967A"/>
+                </a:solidFill>
+                <a:latin typeface="Consolas"/>
+              </a:rPr>
+              <a:t>the last unchecked box before unsupervised roaming.</a:t>
+            </a:r>
+          </a:p>
+        </p:txBody>
+      </p:sp>
+      <p:sp>
+        <p:nvSpPr>
+          <p:cNvPr id="5" name="Rectangle 4"/>
+          <p:cNvSpPr/>
+          <p:nvPr/>
+        </p:nvSpPr>
+        <p:spPr>
+          <a:xfrm>
+            <a:off x="6766560" y="1737360"/>
+            <a:ext cx="4846320" cy="3291840"/>
+          </a:xfrm>
+          <a:prstGeom prst="rect">
+            <a:avLst/>
+          </a:prstGeom>
+          <a:solidFill>
+            <a:srgbClr val="0D130C"/>
+          </a:solidFill>
+          <a:ln w="12700">
+            <a:solidFill>
+              <a:srgbClr val="22331F"/>
+            </a:solidFill>
+          </a:ln>
+        </p:spPr>
+        <p:style>
+          <a:lnRef idx="1">
+            <a:schemeClr val="accent1"/>
+          </a:lnRef>
+          <a:fillRef idx="3">
+            <a:schemeClr val="accent1"/>
+          </a:fillRef>
+          <a:effectRef idx="2">
+            <a:schemeClr val="accent1"/>
+          </a:effectRef>
+          <a:fontRef idx="minor">
+            <a:schemeClr val="lt1"/>
+          </a:fontRef>
+        </p:style>
+        <p:txBody>
+          <a:bodyPr rtlCol="0" anchor="ctr" wrap="none" lIns="120000" tIns="90000"/>
+          <a:lstStyle/>
+          <a:p>
+            <a:pPr algn="ctr">
+              <a:spcAft>
+                <a:spcPts val="200"/>
+              </a:spcAft>
+            </a:pPr>
+            <a:r>
+              <a:rPr sz="1100">
+                <a:solidFill>
+                  <a:srgbClr val="3D9A45"/>
+                </a:solidFill>
+                <a:latin typeface="Consolas"/>
+              </a:rPr>
+              <a:t>SLAM CAMPAIGN (separate track)</a:t>
+            </a:r>
+          </a:p>
+          <a:p>
+            <a:pPr>
+              <a:spcAft>
+                <a:spcPts val="200"/>
+              </a:spcAft>
+            </a:pPr>
+            <a:r>
+              <a:rPr sz="1100">
+                <a:solidFill>
+                  <a:srgbClr val="C9DFC2"/>
+                </a:solidFill>
+                <a:latin typeface="Consolas"/>
+              </a:rPr>
+              <a:t/>
+            </a:r>
+          </a:p>
+          <a:p>
+            <a:pPr>
+              <a:spcAft>
+                <a:spcPts val="200"/>
+              </a:spcAft>
+            </a:pPr>
+            <a:r>
+              <a:rPr sz="1100">
+                <a:solidFill>
+                  <a:srgbClr val="7D967A"/>
+                </a:solidFill>
+                <a:latin typeface="Consolas"/>
+              </a:rPr>
+              <a:t>external review: no metric map possible yet</a:t>
+            </a:r>
+          </a:p>
+          <a:p>
+            <a:pPr>
+              <a:spcAft>
+                <a:spcPts val="200"/>
+              </a:spcAft>
+            </a:pPr>
+            <a:r>
+              <a:rPr sz="1100">
+                <a:solidFill>
+                  <a:srgbClr val="7D967A"/>
+                </a:solidFill>
+                <a:latin typeface="Consolas"/>
+              </a:rPr>
+              <a:t>(VO counts frames not metres; EKF never</a:t>
+            </a:r>
+          </a:p>
+          <a:p>
+            <a:pPr>
+              <a:spcAft>
+                <a:spcPts val="200"/>
+              </a:spcAft>
+            </a:pPr>
+            <a:r>
+              <a:rPr sz="1100">
+                <a:solidFill>
+                  <a:srgbClr val="7D967A"/>
+                </a:solidFill>
+                <a:latin typeface="Consolas"/>
+              </a:rPr>
+              <a:t> sees a real camera measurement)</a:t>
+            </a:r>
+          </a:p>
+          <a:p>
+            <a:pPr>
+              <a:spcAft>
+                <a:spcPts val="200"/>
+              </a:spcAft>
+            </a:pPr>
+            <a:r>
+              <a:rPr sz="1100">
+                <a:solidFill>
+                  <a:srgbClr val="C9DFC2"/>
+                </a:solidFill>
+                <a:latin typeface="Consolas"/>
+              </a:rPr>
+              <a:t/>
+            </a:r>
+          </a:p>
+          <a:p>
+            <a:pPr>
+              <a:spcAft>
+                <a:spcPts val="200"/>
+              </a:spcAft>
+            </a:pPr>
+            <a:r>
+              <a:rPr sz="1100">
+                <a:solidFill>
+                  <a:srgbClr val="C9DFC2"/>
+                </a:solidFill>
+                <a:latin typeface="Consolas"/>
+              </a:rPr>
+              <a:t>phase 1  honest measurement (de-anchor sim)</a:t>
+            </a:r>
+          </a:p>
+          <a:p>
+            <a:pPr>
+              <a:spcAft>
+                <a:spcPts val="200"/>
+              </a:spcAft>
+            </a:pPr>
+            <a:r>
+              <a:rPr sz="1100">
+                <a:solidFill>
+                  <a:srgbClr val="C9DFC2"/>
+                </a:solidFill>
+                <a:latin typeface="Consolas"/>
+              </a:rPr>
+              <a:t>phase 2  keyframe VO</a:t>
+            </a:r>
+          </a:p>
+          <a:p>
+            <a:pPr>
+              <a:spcAft>
+                <a:spcPts val="200"/>
+              </a:spcAft>
+            </a:pPr>
+            <a:r>
+              <a:rPr sz="1100">
+                <a:solidFill>
+                  <a:srgbClr val="FFB454"/>
+                </a:solidFill>
+                <a:latin typeface="Consolas"/>
+              </a:rPr>
+              <a:t>phase 3  metric scale        &lt;- the crux</a:t>
+            </a:r>
+          </a:p>
+          <a:p>
+            <a:pPr>
+              <a:spcAft>
+                <a:spcPts val="200"/>
+              </a:spcAft>
+            </a:pPr>
+            <a:r>
+              <a:rPr sz="1100">
+                <a:solidFill>
+                  <a:srgbClr val="C9DFC2"/>
+                </a:solidFill>
+                <a:latin typeface="Consolas"/>
+              </a:rPr>
+              <a:t>phase 4  real EKF updates</a:t>
+            </a:r>
+          </a:p>
+          <a:p>
+            <a:pPr>
+              <a:spcAft>
+                <a:spcPts val="200"/>
+              </a:spcAft>
+            </a:pPr>
+            <a:r>
+              <a:rPr sz="1100">
+                <a:solidFill>
+                  <a:srgbClr val="C9DFC2"/>
+                </a:solidFill>
+                <a:latin typeface="Consolas"/>
+              </a:rPr>
+              <a:t>phase 5  IMU fusion</a:t>
+            </a:r>
+          </a:p>
+          <a:p>
+            <a:pPr>
+              <a:spcAft>
+                <a:spcPts val="200"/>
+              </a:spcAft>
+            </a:pPr>
+            <a:r>
+              <a:rPr sz="1100">
+                <a:solidFill>
+                  <a:srgbClr val="C9DFC2"/>
+                </a:solidFill>
+                <a:latin typeface="Consolas"/>
+              </a:rPr>
+              <a:t>phase 6  record-replay + hardware ladder</a:t>
+            </a:r>
+          </a:p>
+        </p:txBody>
+      </p:sp>
+    </p:spTree>
+  </p:cSld>
+  <p:clrMapOvr>
+    <a:masterClrMapping/>
+  </p:clrMapOvr>
+</p:sld>
+</file>
+
+<file path=ppt/slides/slide15.xml><?xml version="1.0" encoding="utf-8"?>
 <p:sld xmlns:a="http://schemas.openxmlformats.org/drawingml/2006/main" xmlns:p="http://schemas.openxmlformats.org/presentationml/2006/main" xmlns:r="http://schemas.openxmlformats.org/officeDocument/2006/relationships">
   <p:cSld>
     <p:bg>

</xml_diff>